<commit_message>
Unit 9: Section 2 rework, Section 1 parts 1.2-1.5, Unclogging Cycle in 4.2, Section 5 drop-downs, deck
Co-Authored-By: Claude Opus 5.5 <noreply@anthropic.com>
</commit_message>
<xml_diff>
--- a/Unit decks/Unit 09 - Strategic Unclogging.pptx
+++ b/Unit decks/Unit 09 - Strategic Unclogging.pptx
@@ -10,11 +10,12 @@
     <p:sldId id="258" r:id="rId4"/>
     <p:sldId id="259" r:id="rId5"/>
     <p:sldId id="260" r:id="rId6"/>
+    <p:sldId id="264" r:id="rId10"/>
     <p:sldId id="262" r:id="rId8"/>
     <p:sldId id="281" r:id="rId32"/>
+    <p:sldId id="290" r:id="rId23"/>
     <p:sldId id="286" r:id="rId37"/>
     <p:sldId id="263" r:id="rId9"/>
-    <p:sldId id="264" r:id="rId10"/>
     <p:sldId id="265" r:id="rId11"/>
     <p:sldId id="266" r:id="rId12"/>
     <p:sldId id="287" r:id="rId38"/>
@@ -651,72 +652,376 @@
           <a:lstStyle/>
           <a:p>
             <a:r>
-              <a:rPr lang="en-US" dirty="0"/>
-              <a:t>2.2 — THREE DISCIPLINES OF EXECUTION ENGINEERING (Step through each)
-Content:
-Discipline 1
-Early Identification
-Discipline 2
-Accurate Classification
-Discipline 3
-Targeted Intervention
-Detect Signals Before They Compound
-Leaders must detect the signals that indicate friction is forming. Bottlenecks, repeated coordination failures, declining execution speed, or growing ambiguity in decision rights are all early indicators that a clog is emerging.
-The strategic value of early identification is significant. A clog detected when it is a friction signal requires a targeted structural adjustment. The same clog discovered six months later, after it has compounded into a systemic execution failure, requires a crisis response. The cost — in time, capital, and leadership credibility — is vastly different.
-This discipline requires leaders to build signal literacy: the ability to read organisational patterns as early indicators of structural misalignment.
-Name the Clog Precisely Before Intervening
-Each clog belongs to a specific category of organisational friction. Structural misfit, capability gaps, decision bottlenecks, misaligned incentives, cultural resistance, technological constraints, or leadership avoidance each require fundamentally different forms of intervention.
-The most common diagnostic failure is applying the wrong lever to a correctly identified symptom. A leader who observes “slow execution” and responds by adding resources is applying a capability lever to what may be a decision bottleneck. The additional resources do not accelerate execution because the constraint is approval latency.
-Accurate classification requires resisting the impulse to solve before diagnosing. The first question is “What type of friction is this, and what does it tell us about the system?”
-Pull the Right Lever with Precision
-Once the clog is identified and classified, it must be addressed through the appropriate strategic lever. Clogs rarely clear themselves through trying harder or working more hours. They require a deliberate adjustment to the organisation’s structural, behavioural, and operational settings.
-Targeted intervention means matching the lever to the root cause. It also means accepting that rarely does a single clog require just one fix. A Capability Gap may require both Upgrade (systems) and Reinforce (skills). A Leadership Avoidance clog may require both Clarify (decision rights) and Rebuild Trust (credibility restoration).
-The goal is to develop a leadership rhythm that moves quickly and precisely: Identify the Clog → Select the Lever → Targeted Intervention.</a:t>
-            </a:r>
-            <a:endParaRPr lang="en-US" dirty="0"/>
-          </a:p>
-          <a:p/>
-          <a:p>
-            <a:r>
+              <a:rPr lang="en-GB"/>
+              <a:t>2.1 — THREE DISCIPLINES OF EXECUTION ENGINEERING (Step through each)</a:t>
+            </a:r>
+          </a:p>
+          <a:p>
+            <a:endParaRPr lang="en-GB"/>
+          </a:p>
+          <a:p>
+            <a:r>
+              <a:rPr lang="en-GB"/>
+              <a:t>TEACHING NOTES:</a:t>
+            </a:r>
+          </a:p>
+          <a:p>
+            <a:r>
+              <a:rPr lang="en-GB"/>
+              <a:t>Teach the three disciplines one at a time. For each, teach the discipline, then what it means in people performance and in organisational performance, using the examples on the page.</a:t>
+            </a:r>
+          </a:p>
+          <a:p>
+            <a:endParaRPr lang="en-GB"/>
+          </a:p>
+          <a:p>
+            <a:r>
+              <a:rPr lang="en-GB"/>
+              <a:t>Content:</a:t>
+            </a:r>
+          </a:p>
+          <a:p>
+            <a:r>
+              <a:rPr lang="en-GB"/>
+              <a:t>Discipline 1</a:t>
+            </a:r>
+          </a:p>
+          <a:p>
+            <a:r>
+              <a:rPr lang="en-GB"/>
+              <a:t>Early Identification</a:t>
+            </a:r>
+          </a:p>
+          <a:p>
+            <a:r>
+              <a:rPr lang="en-GB"/>
+              <a:t>Discipline 2</a:t>
+            </a:r>
+          </a:p>
+          <a:p>
+            <a:r>
+              <a:rPr lang="en-GB"/>
+              <a:t>Accurate Classification</a:t>
+            </a:r>
+          </a:p>
+          <a:p>
+            <a:r>
+              <a:rPr lang="en-GB"/>
+              <a:t>Discipline 3</a:t>
+            </a:r>
+          </a:p>
+          <a:p>
+            <a:r>
+              <a:rPr lang="en-GB"/>
+              <a:t>Targeted Intervention</a:t>
+            </a:r>
+          </a:p>
+          <a:p>
+            <a:r>
+              <a:rPr lang="en-GB"/>
+              <a:t>Detect Signals Before They Compound</a:t>
+            </a:r>
+          </a:p>
+          <a:p>
+            <a:r>
+              <a:rPr lang="en-GB"/>
+              <a:t>Leaders must detect the signals that indicate friction is forming. Bottlenecks, repeated coordination failures, declining execution speed, or growing ambiguity in decision rights are all early indicators that a clog is emerging.</a:t>
+            </a:r>
+          </a:p>
+          <a:p>
+            <a:r>
+              <a:rPr lang="en-GB"/>
+              <a:t>The strategic value of early identification is significant. A clog detected when it is a friction signal requires a targeted structural adjustment. The same clog discovered six months later, after it has compounded into a systemic execution failure, requires a crisis response. The cost — in time, capital, and leadership credibility — is vastly different.</a:t>
+            </a:r>
+          </a:p>
+          <a:p>
+            <a:r>
+              <a:rPr lang="en-GB"/>
+              <a:t>This discipline requires leaders to build signal literacy: the ability to read organisational patterns as early indicators of structural misalignment.</a:t>
+            </a:r>
+          </a:p>
+          <a:p>
+            <a:r>
+              <a:rPr lang="en-GB"/>
+              <a:t>Early signals appear in the rhythm of work before they appear in the results. Leaders find them in three places: in the review, where the same items carry forward and explanations replace progress; in the flow of work, where hand-offs slow, approvals queue and workarounds multiply; and in conversation, where people stop raising problems or raise the same one repeatedly.</a:t>
+            </a:r>
+          </a:p>
+          <a:p>
+            <a:r>
+              <a:rPr lang="en-GB"/>
+              <a:t>The early warning signals listed for each of the seven clogs give leaders a reference to read against. Signal literacy grows through practice: leaders ask for the signals in every review, compare them across functions and record them before the result moves.</a:t>
+            </a:r>
+          </a:p>
+          <a:p>
+            <a:r>
+              <a:rPr lang="en-GB"/>
+              <a:t>People performance</a:t>
+            </a:r>
+          </a:p>
+          <a:p>
+            <a:r>
+              <a:rPr lang="en-GB"/>
+              <a:t>Leaders read the signals in how individuals and teams work: decisions held for approval that the individual could take, rework rising on the same tasks, longer hours for the same output, and silence in meetings where challenge is needed. These signals appear before the KPI falls. Leaders who ask a team what is slowing its work hear them within weeks; a review that reads only the KPI sees them a quarter later.</a:t>
+            </a:r>
+          </a:p>
+          <a:p>
+            <a:r>
+              <a:rPr lang="en-GB"/>
+              <a:t>Organisational performance</a:t>
+            </a:r>
+          </a:p>
+          <a:p>
+            <a:r>
+              <a:rPr lang="en-GB"/>
+              <a:t>Leaders read the signals in the organisational conditions that support the execution of the individuals’ tasks.</a:t>
+            </a:r>
+          </a:p>
+          <a:p>
+            <a:r>
+              <a:rPr lang="en-GB"/>
+              <a:t>Governance · review forums. The same unresolved item appears on three consecutive agendas, and each team waiting on it reports its delay separately.</a:t>
+            </a:r>
+          </a:p>
+          <a:p>
+            <a:r>
+              <a:rPr lang="en-GB"/>
+              <a:t>Systems · data integrity. Two reports give different figures for the same measure, and teams spend their time reconciling them.</a:t>
+            </a:r>
+          </a:p>
+          <a:p>
+            <a:r>
+              <a:rPr lang="en-GB"/>
+              <a:t>Resources · workforce capacity. One specialist’s queue grows each week while the projects that depend on that person report small slips.</a:t>
+            </a:r>
+          </a:p>
+          <a:p>
+            <a:r>
+              <a:rPr lang="en-GB"/>
+              <a:t>None of these carries a number in the review, so leaders ask for them by name.</a:t>
+            </a:r>
+          </a:p>
+          <a:p>
+            <a:r>
+              <a:rPr lang="en-GB"/>
+              <a:t>Name the Clog Precisely Before Intervening</a:t>
+            </a:r>
+          </a:p>
+          <a:p>
+            <a:r>
+              <a:rPr lang="en-GB"/>
+              <a:t>Each clog belongs to a specific category of organisational friction. Structural misfit, capability gaps, decision bottlenecks, misaligned incentives, cultural resistance, technological constraints, or leadership avoidance each require fundamentally different forms of intervention.</a:t>
+            </a:r>
+          </a:p>
+          <a:p>
+            <a:r>
+              <a:rPr lang="en-GB"/>
+              <a:t>The most common diagnostic failure is applying the wrong lever to a correctly identified symptom. A leader who observes “slow execution” and responds by adding resources is applying a capability lever to what may be a decision bottleneck. The additional resources do not accelerate execution because the constraint is approval latency.</a:t>
+            </a:r>
+          </a:p>
+          <a:p>
+            <a:r>
+              <a:rPr lang="en-GB"/>
+              <a:t>Accurate classification requires resisting the impulse to solve before diagnosing. The first question is “What type of friction is this, and what does it tell us about the system?”</a:t>
+            </a:r>
+          </a:p>
+          <a:p>
+            <a:r>
+              <a:rPr lang="en-GB"/>
+              <a:t>Classification uses the evidence of the Three Performance Lines of Sight. The outcome confirms that a clog exists. The behaviour shows how it acts on individuals and teams. The condition names the clog. Leaders test the evidence against each of the seven clogs in turn and keep the one that explains why the pattern persists.</a:t>
+            </a:r>
+          </a:p>
+          <a:p>
+            <a:r>
+              <a:rPr lang="en-GB"/>
+              <a:t>Several clogs often act together. Leaders name the primary clog, the one whose removal releases the others, and record the contributing clogs beside it.</a:t>
+            </a:r>
+          </a:p>
+          <a:p>
+            <a:r>
+              <a:rPr lang="en-GB"/>
+              <a:t>People performance</a:t>
+            </a:r>
+          </a:p>
+          <a:p>
+            <a:r>
+              <a:rPr lang="en-GB"/>
+              <a:t>Leaders separate what is within the individual’s control from what the conditions impose. An individual who delays decisions may lack confidence. The same delay appears when the individual lacks the authority to decide. Classification establishes which applies, with evidence from the individual’s work, before a capability or accountability response is chosen.</a:t>
+            </a:r>
+          </a:p>
+          <a:p>
+            <a:r>
+              <a:rPr lang="en-GB"/>
+              <a:t>Organisational performance</a:t>
+            </a:r>
+          </a:p>
+          <a:p>
+            <a:r>
+              <a:rPr lang="en-GB"/>
+              <a:t>Leaders locate the condition behind the behaviour.</a:t>
+            </a:r>
+          </a:p>
+          <a:p>
+            <a:r>
+              <a:rPr lang="en-GB"/>
+              <a:t>Governance · decision authority. Approvals for routine work sit two levels above the people doing it. The slow delivery is a Decision Bottleneck.</a:t>
+            </a:r>
+          </a:p>
+          <a:p>
+            <a:r>
+              <a:rPr lang="en-GB"/>
+              <a:t>Systems · process clarity. The hand-offs between three functions have no single owner. The same slow delivery is Structural Misfit.</a:t>
+            </a:r>
+          </a:p>
+          <a:p>
+            <a:r>
+              <a:rPr lang="en-GB"/>
+              <a:t>One symptom leads to two different clogs, and to two different levers. Classification decides which one the team pulls.</a:t>
+            </a:r>
+          </a:p>
+          <a:p>
+            <a:r>
+              <a:rPr lang="en-GB"/>
+              <a:t>Pull the Right Lever with Precision</a:t>
+            </a:r>
+          </a:p>
+          <a:p>
+            <a:r>
+              <a:rPr lang="en-GB"/>
+              <a:t>Once the clog is identified and classified, it must be addressed through the appropriate strategic lever. Clogs rarely clear themselves through trying harder or working more hours. They require a deliberate adjustment to the organisation’s structural, behavioural, and operational settings.</a:t>
+            </a:r>
+          </a:p>
+          <a:p>
+            <a:r>
+              <a:rPr lang="en-GB"/>
+              <a:t>Targeted intervention means matching the lever to the root cause. It also means accepting that rarely does a single clog require just one fix. A Capability Gap may require both Upgrade (systems) and Reinforce (skills). A Leadership Avoidance clog may require both Clarify (decision rights) and Rebuild Trust (credibility restoration).</a:t>
+            </a:r>
+          </a:p>
+          <a:p>
+            <a:r>
+              <a:rPr lang="en-GB"/>
+              <a:t>A targeted intervention names what will change, who will change it and the evidence that will show the clog clearing. Leaders set that evidence before they act: the signal they expect to fall, the behaviour they expect to change and the result they expect to move.</a:t>
+            </a:r>
+          </a:p>
+          <a:p>
+            <a:r>
+              <a:rPr lang="en-GB"/>
+              <a:t>Leaders also sequence the response. Where two levers are needed, the lever that changes the condition usually comes first, and the lever that builds the people’s capability or confidence follows, so that individuals apply new skills in conditions that support them.</a:t>
+            </a:r>
+          </a:p>
+          <a:p>
+            <a:r>
+              <a:rPr lang="en-GB"/>
+              <a:t>People performance</a:t>
+            </a:r>
+          </a:p>
+          <a:p>
+            <a:r>
+              <a:rPr lang="en-GB"/>
+              <a:t>The intervention equips individuals to deliver their tasks under the changed conditions: clear authority, the skills the strategy now requires, coaching through the first cycles and consistent consequences. Leaders confirm the change in the individuals’ work: decisions taken at the right level, less rework and problems raised early.</a:t>
+            </a:r>
+          </a:p>
+          <a:p>
+            <a:r>
+              <a:rPr lang="en-GB"/>
+              <a:t>Organisational performance</a:t>
+            </a:r>
+          </a:p>
+          <a:p>
+            <a:r>
+              <a:rPr lang="en-GB"/>
+              <a:t>The intervention changes the organisational condition behind the clog.</a:t>
+            </a:r>
+          </a:p>
+          <a:p>
+            <a:r>
+              <a:rPr lang="en-GB"/>
+              <a:t>Governance · decision authority. Delegation limits for routine decisions are reset and published.</a:t>
+            </a:r>
+          </a:p>
+          <a:p>
+            <a:r>
+              <a:rPr lang="en-GB"/>
+              <a:t>Systems · data integrity. One source of customer data replaces three, and every report draws on it.</a:t>
+            </a:r>
+          </a:p>
+          <a:p>
+            <a:r>
+              <a:rPr lang="en-GB"/>
+              <a:t>Resources · capability alignment. Specialist capacity is added where the strategy concentrates demand.</a:t>
+            </a:r>
+          </a:p>
+          <a:p>
+            <a:r>
+              <a:rPr lang="en-GB"/>
+              <a:t>Leaders confirm the change in the condition itself, then in the Key Result.</a:t>
+            </a:r>
+          </a:p>
+          <a:p>
+            <a:r>
+              <a:rPr lang="en-GB"/>
+              <a:t>The goal is to develop a leadership rhythm that moves quickly and precisely: Identify the Clog → Select the Lever → Targeted Intervention.</a:t>
+            </a:r>
+          </a:p>
+          <a:p>
+            <a:endParaRPr lang="en-GB"/>
+          </a:p>
+          <a:p>
+            <a:r>
+              <a:rPr lang="en-GB"/>
               <a:t>Source detail (S2R® manuscript):</a:t>
             </a:r>
           </a:p>
-          <a:p/>
-          <a:p>
-            <a:r>
+          <a:p>
+            <a:endParaRPr lang="en-GB"/>
+          </a:p>
+          <a:p>
+            <a:r>
+              <a:rPr lang="en-GB"/>
               <a:t>From diagnosis to intervention: Once a clog is identified, the leadership task shifts from diagnosis to intervention. The deliberate adjustment is to the organisation’s “plumbing”: the structural, behavioural, and operational settings that dictate how work actually gets done.</a:t>
             </a:r>
           </a:p>
           <a:p>
             <a:r>
+              <a:rPr lang="en-GB"/>
               <a:t>What mastery of the rhythm gives: When leaders master this, execution stops being a stressful, reactive struggle. It becomes a resilient, continuous process of adjustment, allowing them to execute consistently and at scale.</a:t>
             </a:r>
           </a:p>
-          <a:p/>
-          <a:p>
-            <a:r>
+          <a:p>
+            <a:endParaRPr lang="en-GB"/>
+          </a:p>
+          <a:p>
+            <a:r>
+              <a:rPr lang="en-GB"/>
               <a:t>Professional insights:</a:t>
             </a:r>
           </a:p>
-          <a:p/>
-          <a:p>
-            <a:r>
+          <a:p>
+            <a:endParaRPr lang="en-GB"/>
+          </a:p>
+          <a:p>
+            <a:r>
+              <a:rPr lang="en-GB"/>
               <a:t>Early Identification: Confident diagnosis from incomplete data is a common failure. Distinguish present difficulty from final outcome.</a:t>
             </a:r>
           </a:p>
           <a:p>
             <a:r>
+              <a:rPr lang="en-GB"/>
               <a:t>Source: Journal, 21 August 2026 — Professional Insights: Strategy</a:t>
             </a:r>
           </a:p>
-          <a:p/>
-          <a:p>
-            <a:r>
+          <a:p>
+            <a:endParaRPr lang="en-GB"/>
+          </a:p>
+          <a:p>
+            <a:r>
+              <a:rPr lang="en-GB"/>
               <a:t>Accurate Classification: Misdiagnosis leads to wrong action. Challenge the assumptions behind a diagnosis before choosing the intervention.</a:t>
             </a:r>
           </a:p>
           <a:p>
             <a:r>
+              <a:rPr lang="en-GB"/>
               <a:t>Source: Journal, 5 July 2026 — Professional Insights: Strategy</a:t>
             </a:r>
           </a:p>
@@ -803,115 +1108,646 @@
           <a:lstStyle/>
           <a:p>
             <a:r>
-              <a:rPr lang="en-US" dirty="0"/>
-              <a:t>2.3 — THE 7 STRATEGIC UNCLOGGING LEVERS (Select each lever to explore)
-Lever Selection Principle
-Identifying a clog is only half the work. The real discipline is lever selection. Rarely does a clog require just one fix. If the clog is a Capability Gap, the leaders may need to Upgrade the systems while simultaneously Reinforcing the team’s skills. If the clog is Leadership Avoidance, there will likely be a need to Clarify decision rights and Rebuild Trust to move forward. Always ask: “Which lever combination addresses the root cause?”
-Content:
-Think of these seven levers as the leadership toolkit for execution architecture. They restore the conditions that allow the strategy to move through the organisation at the speed and quality intended. Each lever targets a specific dimension of the system.
-Lever 01
-Standardise
-Ensure Consistency
-Harmonises processes and service levels across teams so everyone plays by the same rules.
-Variability is a silent killer of speed. By establishing a shared “way we work,” you reduce duplication and ensure every unit pulls in the same direction. Best applied to: Structural Misfit, Misaligned Metrics &amp; Incentives, Technology / Infrastructure Lag.
-Lever 02
-Streamline
-Increase Speed
-Simplifies workflows and removes the red tape layers that add no value to execution.
-Leaner processes mean faster approvals and a team that can pivot as quickly as the market demands. Best applied to: Decision Bottlenecks, Structural Misfit.
-Lever 03
-Clarify
-Eliminate Confusion
-Defines exactly who owns what, where the handoffs are, and who has the final say.
-Ambiguity breeds hesitation. When people know their roles and decision rights, accountability returns and work stops getting stuck in limbo. Best applied to: Decision Bottlenecks, Structural Misfit, Leadership Avoidance.
-Lever 04
-Upgrade
-Remove Bottlenecks
-Fixes underperforming technology and infrastructure that holds execution back.
-You cannot run a modern strategy on yesterday’s tools. Upgrading removes the physical and digital friction that makes scaling feel impossible. Best applied to: Technology / Infrastructure Lag, Capability Gaps.
-Lever 05
-Reinforce
-Strengthen Behaviour
-Equips the team with the skills, coaching, and confidence they need to actually deliver.
-Strategy requires new behaviours. Reinforcement ensures your people are capable of making the change. Best applied to: Capability Gaps, Cultural Resistance.
-Lever 06
-Realign
-Focus on Results
-Adjusts metrics and rewards so they actually match current strategic priorities.
-People do what they are measured on. When you fix the incentives, the team’s energy naturally shifts from protecting their patch to creating enterprise value. Best applied to: Misaligned Metrics &amp; Incentives.
-Lever 07
-Rebuild Trust
-Restore Credibility
-Heals relationships and introduces the transparency needed for people to commit again.
-Trust is the social grease of execution. Without it, the system seizes up. Rebuilding it restores the psychological safety required for high-stakes work. Best applied to: Cultural Resistance, Leadership Avoidance.
-Participant file (2.3 — The 7 Strategic Unclogging Levers) — prompts participants complete:
-- ✎ Reflection — Your Lever — For the clog you identified in Awareness: Which primary lever would you pull? Which secondary lever would you combine it with? Why this combination?</a:t>
-            </a:r>
-            <a:endParaRPr lang="en-US" dirty="0"/>
-          </a:p>
-          <a:p/>
-          <a:p>
-            <a:r>
+              <a:rPr lang="en-GB"/>
+              <a:t>2.2 — THE 7 STRATEGIC UNCLOGGING LEVERS (Select each lever to explore)</a:t>
+            </a:r>
+          </a:p>
+          <a:p>
+            <a:endParaRPr lang="en-GB"/>
+          </a:p>
+          <a:p>
+            <a:r>
+              <a:rPr lang="en-GB"/>
+              <a:t>TEACHING NOTES:</a:t>
+            </a:r>
+          </a:p>
+          <a:p>
+            <a:r>
+              <a:rPr lang="en-GB"/>
+              <a:t>Open the levers one at a time: what the lever does, how it works, and what it changes in people performance and in organisational performance. Rarely does a single lever clear a clog alone: ask which lever combination addresses the root cause.</a:t>
+            </a:r>
+          </a:p>
+          <a:p>
+            <a:endParaRPr lang="en-GB"/>
+          </a:p>
+          <a:p>
+            <a:r>
+              <a:rPr lang="en-GB"/>
+              <a:t>Content:</a:t>
+            </a:r>
+          </a:p>
+          <a:p>
+            <a:r>
+              <a:rPr lang="en-GB"/>
+              <a:t>Think of these seven levers as the leadership toolkit for execution architecture. They restore the conditions that allow the strategy to move through the organisation at the speed and quality intended. Each lever targets a specific dimension of the system.</a:t>
+            </a:r>
+          </a:p>
+          <a:p>
+            <a:r>
+              <a:rPr lang="en-GB"/>
+              <a:t>Lever 01</a:t>
+            </a:r>
+          </a:p>
+          <a:p>
+            <a:r>
+              <a:rPr lang="en-GB"/>
+              <a:t>Standardise</a:t>
+            </a:r>
+          </a:p>
+          <a:p>
+            <a:r>
+              <a:rPr lang="en-GB"/>
+              <a:t>Ensure Consistency</a:t>
+            </a:r>
+          </a:p>
+          <a:p>
+            <a:r>
+              <a:rPr lang="en-GB"/>
+              <a:t>▼</a:t>
+            </a:r>
+          </a:p>
+          <a:p>
+            <a:r>
+              <a:rPr lang="en-GB"/>
+              <a:t>Harmonises processes and service levels across teams so everyone plays by the same rules.</a:t>
+            </a:r>
+          </a:p>
+          <a:p>
+            <a:r>
+              <a:rPr lang="en-GB"/>
+              <a:t>Variability is a silent killer of speed. By establishing a shared “way we work,” you reduce duplication and ensure every unit pulls in the same direction. Apply when: Variability across teams is creating drag. Best applied to: Structural Misfit, Misaligned Metrics &amp; Incentives, Technology / Infrastructure Lag.</a:t>
+            </a:r>
+          </a:p>
+          <a:p>
+            <a:r>
+              <a:rPr lang="en-GB"/>
+              <a:t>How it works. Standardise sets one agreed way of working where the strategy needs consistent results across teams, sites or channels. Leaders define the standard, the measure that shows it is met and the leader responsible for keeping it current. The standard covers the work that must be consistent and leaves local judgement where the strategy needs it.</a:t>
+            </a:r>
+          </a:p>
+          <a:p>
+            <a:r>
+              <a:rPr lang="en-GB"/>
+              <a:t>People performance</a:t>
+            </a:r>
+          </a:p>
+          <a:p>
+            <a:r>
+              <a:rPr lang="en-GB"/>
+              <a:t>Individuals work to one set of expectations, so effort is no longer lost translating between teams. Leaders train every team on the standard and hold each individual to the same measure of quality and timeliness.</a:t>
+            </a:r>
+          </a:p>
+          <a:p>
+            <a:r>
+              <a:rPr lang="en-GB"/>
+              <a:t>Organisational performance</a:t>
+            </a:r>
+          </a:p>
+          <a:p>
+            <a:r>
+              <a:rPr lang="en-GB"/>
+              <a:t>Systems · process clarity. Three regions run three versions of customer onboarding. One process replaces them, with one set of service levels.</a:t>
+            </a:r>
+          </a:p>
+          <a:p>
+            <a:r>
+              <a:rPr lang="en-GB"/>
+              <a:t>Governance · clear accountability. A named leader maintains the standard and reviews compliance each quarter.</a:t>
+            </a:r>
+          </a:p>
+          <a:p>
+            <a:r>
+              <a:rPr lang="en-GB"/>
+              <a:t>Lever 02</a:t>
+            </a:r>
+          </a:p>
+          <a:p>
+            <a:r>
+              <a:rPr lang="en-GB"/>
+              <a:t>Streamline</a:t>
+            </a:r>
+          </a:p>
+          <a:p>
+            <a:r>
+              <a:rPr lang="en-GB"/>
+              <a:t>Increase Speed</a:t>
+            </a:r>
+          </a:p>
+          <a:p>
+            <a:r>
+              <a:rPr lang="en-GB"/>
+              <a:t>▼</a:t>
+            </a:r>
+          </a:p>
+          <a:p>
+            <a:r>
+              <a:rPr lang="en-GB"/>
+              <a:t>Simplifies workflows and removes the red tape layers that add no value to execution.</a:t>
+            </a:r>
+          </a:p>
+          <a:p>
+            <a:r>
+              <a:rPr lang="en-GB"/>
+              <a:t>Leaner processes mean faster approvals and a team that can pivot as quickly as the market demands. Apply when: Approval processes are creating latency. Best applied to: Decision Bottlenecks, Structural Misfit.</a:t>
+            </a:r>
+          </a:p>
+          <a:p>
+            <a:r>
+              <a:rPr lang="en-GB"/>
+              <a:t>How it works. Streamline removes the steps, approvals and hand-offs that add time without adding control or value. Leaders map the path a piece of work takes, mark each point where it waits, and remove or combine the steps that change nothing in the outcome. Controls that protect the organisation stay, placed at the point of greatest risk.</a:t>
+            </a:r>
+          </a:p>
+          <a:p>
+            <a:r>
+              <a:rPr lang="en-GB"/>
+              <a:t>People performance</a:t>
+            </a:r>
+          </a:p>
+          <a:p>
+            <a:r>
+              <a:rPr lang="en-GB"/>
+              <a:t>Individuals spend their time on the task itself. Managers decide within clear limits, teams stop chasing approvals, and work moves at the pace the strategy requires.</a:t>
+            </a:r>
+          </a:p>
+          <a:p>
+            <a:r>
+              <a:rPr lang="en-GB"/>
+              <a:t>Organisational performance</a:t>
+            </a:r>
+          </a:p>
+          <a:p>
+            <a:r>
+              <a:rPr lang="en-GB"/>
+              <a:t>Governance · decision authority. Routine purchases below an agreed limit no longer need senior approval.</a:t>
+            </a:r>
+          </a:p>
+          <a:p>
+            <a:r>
+              <a:rPr lang="en-GB"/>
+              <a:t>Systems · approvals. One electronic approval route replaces email chains, and every request shows where it sits.</a:t>
+            </a:r>
+          </a:p>
+          <a:p>
+            <a:r>
+              <a:rPr lang="en-GB"/>
+              <a:t>Lever 03</a:t>
+            </a:r>
+          </a:p>
+          <a:p>
+            <a:r>
+              <a:rPr lang="en-GB"/>
+              <a:t>Clarify</a:t>
+            </a:r>
+          </a:p>
+          <a:p>
+            <a:r>
+              <a:rPr lang="en-GB"/>
+              <a:t>Eliminate Confusion</a:t>
+            </a:r>
+          </a:p>
+          <a:p>
+            <a:r>
+              <a:rPr lang="en-GB"/>
+              <a:t>▼</a:t>
+            </a:r>
+          </a:p>
+          <a:p>
+            <a:r>
+              <a:rPr lang="en-GB"/>
+              <a:t>Defines exactly who owns what, where the handoffs are, and who has the final say.</a:t>
+            </a:r>
+          </a:p>
+          <a:p>
+            <a:r>
+              <a:rPr lang="en-GB"/>
+              <a:t>Ambiguity breeds hesitation. When people know their roles and decision rights, accountability returns and work stops getting stuck in limbo. Apply when: Ownership ambiguity is causing hesitation. Best applied to: Decision Bottlenecks, Structural Misfit, Leadership Avoidance.</a:t>
+            </a:r>
+          </a:p>
+          <a:p>
+            <a:r>
+              <a:rPr lang="en-GB"/>
+              <a:t>How it works. Clarify settles who owns each outcome, who decides, who must be consulted and where work passes from one team to the next. Leaders write the decision rights and hand-offs down, agree them across the functions involved and communicate them to everyone who works across the boundary.</a:t>
+            </a:r>
+          </a:p>
+          <a:p>
+            <a:r>
+              <a:rPr lang="en-GB"/>
+              <a:t>People performance</a:t>
+            </a:r>
+          </a:p>
+          <a:p>
+            <a:r>
+              <a:rPr lang="en-GB"/>
+              <a:t>Individuals know which decisions are theirs and act on them. Escalation falls, ownership returns to the level closest to the work, and accountability can be applied fairly because responsibility now carries matching authority.</a:t>
+            </a:r>
+          </a:p>
+          <a:p>
+            <a:r>
+              <a:rPr lang="en-GB"/>
+              <a:t>Organisational performance</a:t>
+            </a:r>
+          </a:p>
+          <a:p>
+            <a:r>
+              <a:rPr lang="en-GB"/>
+              <a:t>Governance · clear accountability. One executive owns the end-to-end customer-resolution outcome across service, operations and finance.</a:t>
+            </a:r>
+          </a:p>
+          <a:p>
+            <a:r>
+              <a:rPr lang="en-GB"/>
+              <a:t>Governance · review forums. Each open trade-off has a named decision-maker and a date by which the decision is made.</a:t>
+            </a:r>
+          </a:p>
+          <a:p>
+            <a:r>
+              <a:rPr lang="en-GB"/>
+              <a:t>Lever 04</a:t>
+            </a:r>
+          </a:p>
+          <a:p>
+            <a:r>
+              <a:rPr lang="en-GB"/>
+              <a:t>Upgrade</a:t>
+            </a:r>
+          </a:p>
+          <a:p>
+            <a:r>
+              <a:rPr lang="en-GB"/>
+              <a:t>Remove Bottlenecks</a:t>
+            </a:r>
+          </a:p>
+          <a:p>
+            <a:r>
+              <a:rPr lang="en-GB"/>
+              <a:t>▼</a:t>
+            </a:r>
+          </a:p>
+          <a:p>
+            <a:r>
+              <a:rPr lang="en-GB"/>
+              <a:t>Fixes underperforming technology and infrastructure that holds execution back.</a:t>
+            </a:r>
+          </a:p>
+          <a:p>
+            <a:r>
+              <a:rPr lang="en-GB"/>
+              <a:t>You cannot run a modern strategy on yesterday’s tools. Upgrading removes the physical and digital friction that makes scaling feel impossible. Apply when: Systems are creating friction that blocks flow. Best applied to: Technology / Infrastructure Lag, Capability Gaps.</a:t>
+            </a:r>
+          </a:p>
+          <a:p>
+            <a:r>
+              <a:rPr lang="en-GB"/>
+              <a:t>How it works. Upgrade replaces or improves the technology, infrastructure or capability that cannot carry the strategy’s demands. Leaders define the performance the strategy requires in speed, reliability, visibility and scale, measure the gap and invest where the gap constrains the Key Result most.</a:t>
+            </a:r>
+          </a:p>
+          <a:p>
+            <a:r>
+              <a:rPr lang="en-GB"/>
+              <a:t>People performance</a:t>
+            </a:r>
+          </a:p>
+          <a:p>
+            <a:r>
+              <a:rPr lang="en-GB"/>
+              <a:t>Individuals stop spending their time on workarounds: re-keying data, reconciling records and building reports by hand. That time returns to the work the strategy needs, and confidence in improvement initiatives recovers.</a:t>
+            </a:r>
+          </a:p>
+          <a:p>
+            <a:r>
+              <a:rPr lang="en-GB"/>
+              <a:t>Organisational performance</a:t>
+            </a:r>
+          </a:p>
+          <a:p>
+            <a:r>
+              <a:rPr lang="en-GB"/>
+              <a:t>Systems · data integrity. The customer and transport systems are connected, so delivery status updates without manual entry.</a:t>
+            </a:r>
+          </a:p>
+          <a:p>
+            <a:r>
+              <a:rPr lang="en-GB"/>
+              <a:t>Environment · infrastructure. Field teams receive reliable connectivity, so orders reach operations the same day.</a:t>
+            </a:r>
+          </a:p>
+          <a:p>
+            <a:r>
+              <a:rPr lang="en-GB"/>
+              <a:t>Lever 05</a:t>
+            </a:r>
+          </a:p>
+          <a:p>
+            <a:r>
+              <a:rPr lang="en-GB"/>
+              <a:t>Reinforce</a:t>
+            </a:r>
+          </a:p>
+          <a:p>
+            <a:r>
+              <a:rPr lang="en-GB"/>
+              <a:t>Strengthen Behaviour</a:t>
+            </a:r>
+          </a:p>
+          <a:p>
+            <a:r>
+              <a:rPr lang="en-GB"/>
+              <a:t>▼</a:t>
+            </a:r>
+          </a:p>
+          <a:p>
+            <a:r>
+              <a:rPr lang="en-GB"/>
+              <a:t>Equips the team with the skills, coaching, and confidence they need to actually deliver.</a:t>
+            </a:r>
+          </a:p>
+          <a:p>
+            <a:r>
+              <a:rPr lang="en-GB"/>
+              <a:t>Strategy requires new behaviours. Reinforcement ensures your people are capable of making the change. Apply when: Skills or confidence are the limiting factor. Best applied to: Capability Gaps, Cultural Resistance.</a:t>
+            </a:r>
+          </a:p>
+          <a:p>
+            <a:r>
+              <a:rPr lang="en-GB"/>
+              <a:t>How it works. Reinforce builds the skills, habits and confidence the strategy requires of individuals and teams. Leaders identify the behaviours the strategy depends on, provide training and coaching, model the behaviours themselves and recognise them when they appear.</a:t>
+            </a:r>
+          </a:p>
+          <a:p>
+            <a:r>
+              <a:rPr lang="en-GB"/>
+              <a:t>People performance</a:t>
+            </a:r>
+          </a:p>
+          <a:p>
+            <a:r>
+              <a:rPr lang="en-GB"/>
+              <a:t>Individuals gain the capability to meet the new expectations and the confidence to apply it. Coaching through the first cycles turns new skills into habits, and recognition shows people that the new behaviours count.</a:t>
+            </a:r>
+          </a:p>
+          <a:p>
+            <a:r>
+              <a:rPr lang="en-GB"/>
+              <a:t>Organisational performance</a:t>
+            </a:r>
+          </a:p>
+          <a:p>
+            <a:r>
+              <a:rPr lang="en-GB"/>
+              <a:t>Resources · capability alignment. A development programme in digital credit assessment is funded for the whole lending team.</a:t>
+            </a:r>
+          </a:p>
+          <a:p>
+            <a:r>
+              <a:rPr lang="en-GB"/>
+              <a:t>Environment · values and consequences. Leaders’ own decisions and recognition reflect the behaviours the strategy asks for.</a:t>
+            </a:r>
+          </a:p>
+          <a:p>
+            <a:r>
+              <a:rPr lang="en-GB"/>
+              <a:t>Lever 06</a:t>
+            </a:r>
+          </a:p>
+          <a:p>
+            <a:r>
+              <a:rPr lang="en-GB"/>
+              <a:t>Realign</a:t>
+            </a:r>
+          </a:p>
+          <a:p>
+            <a:r>
+              <a:rPr lang="en-GB"/>
+              <a:t>Focus on Results</a:t>
+            </a:r>
+          </a:p>
+          <a:p>
+            <a:r>
+              <a:rPr lang="en-GB"/>
+              <a:t>▼</a:t>
+            </a:r>
+          </a:p>
+          <a:p>
+            <a:r>
+              <a:rPr lang="en-GB"/>
+              <a:t>Adjusts metrics and rewards so they actually match current strategic priorities.</a:t>
+            </a:r>
+          </a:p>
+          <a:p>
+            <a:r>
+              <a:rPr lang="en-GB"/>
+              <a:t>People do what they are measured on. When you fix the incentives, the team’s energy naturally shifts from protecting their patch to creating enterprise value. Apply when: Effort is flowing only to what is measured. Best applied to: Misaligned Metrics &amp; Incentives.</a:t>
+            </a:r>
+          </a:p>
+          <a:p>
+            <a:r>
+              <a:rPr lang="en-GB"/>
+              <a:t>How it works. Realign changes measures, targets and rewards so that they reinforce the contributions the strategy needs. Leaders trace each scorecard measure to the Key Result it serves, remove or reweight the measures that reward local results at the expense of the enterprise outcome, and add measures for shared results.</a:t>
+            </a:r>
+          </a:p>
+          <a:p>
+            <a:r>
+              <a:rPr lang="en-GB"/>
+              <a:t>People performance</a:t>
+            </a:r>
+          </a:p>
+          <a:p>
+            <a:r>
+              <a:rPr lang="en-GB"/>
+              <a:t>Individuals no longer have to choose between their rating and the strategy. Collaboration, quality and contribution to shared outcomes are recognised, so committed people can do what the strategy requires without personal cost.</a:t>
+            </a:r>
+          </a:p>
+          <a:p>
+            <a:r>
+              <a:rPr lang="en-GB"/>
+              <a:t>Organisational performance</a:t>
+            </a:r>
+          </a:p>
+          <a:p>
+            <a:r>
+              <a:rPr lang="en-GB"/>
+              <a:t>Governance · consistent consequences. Sales bonuses are paid on margin and customer retention alongside volume.</a:t>
+            </a:r>
+          </a:p>
+          <a:p>
+            <a:r>
+              <a:rPr lang="en-GB"/>
+              <a:t>Systems · performance data. Shared enterprise measures appear on every functional scorecard that contributes to them.</a:t>
+            </a:r>
+          </a:p>
+          <a:p>
+            <a:r>
+              <a:rPr lang="en-GB"/>
+              <a:t>Lever 07</a:t>
+            </a:r>
+          </a:p>
+          <a:p>
+            <a:r>
+              <a:rPr lang="en-GB"/>
+              <a:t>Rebuild Trust</a:t>
+            </a:r>
+          </a:p>
+          <a:p>
+            <a:r>
+              <a:rPr lang="en-GB"/>
+              <a:t>Restore Credibility</a:t>
+            </a:r>
+          </a:p>
+          <a:p>
+            <a:r>
+              <a:rPr lang="en-GB"/>
+              <a:t>▼</a:t>
+            </a:r>
+          </a:p>
+          <a:p>
+            <a:r>
+              <a:rPr lang="en-GB"/>
+              <a:t>Heals relationships and introduces the transparency needed for people to commit again.</a:t>
+            </a:r>
+          </a:p>
+          <a:p>
+            <a:r>
+              <a:rPr lang="en-GB"/>
+              <a:t>Trust is the social grease of execution. Without it, the system seizes up. Rebuilding it restores the psychological safety required for high-stakes work. Apply when: Psychological safety or leadership credibility is the constraint. Best applied to: Cultural Resistance, Leadership Avoidance.</a:t>
+            </a:r>
+          </a:p>
+          <a:p>
+            <a:r>
+              <a:rPr lang="en-GB"/>
+              <a:t>How it works. Rebuild Trust restores the credibility of leadership and the safety people need to speak, challenge and commit. Leaders acknowledge what has gone wrong, act on the concerns people raise, follow through on their decisions and make the reasons for those decisions visible.</a:t>
+            </a:r>
+          </a:p>
+          <a:p>
+            <a:r>
+              <a:rPr lang="en-GB"/>
+              <a:t>People performance</a:t>
+            </a:r>
+          </a:p>
+          <a:p>
+            <a:r>
+              <a:rPr lang="en-GB"/>
+              <a:t>Individuals raise problems early again, offer ideas and commit to decisions they helped shape. Strong performers regain confidence in the direction.</a:t>
+            </a:r>
+          </a:p>
+          <a:p>
+            <a:r>
+              <a:rPr lang="en-GB"/>
+              <a:t>Organisational performance</a:t>
+            </a:r>
+          </a:p>
+          <a:p>
+            <a:r>
+              <a:rPr lang="en-GB"/>
+              <a:t>Environment · psychological safety. Leaders open each review by asking what is blocking delivery, and act on what they hear.</a:t>
+            </a:r>
+          </a:p>
+          <a:p>
+            <a:r>
+              <a:rPr lang="en-GB"/>
+              <a:t>Governance · consistent consequences. Commitments missed at senior level are addressed to the same standard applied elsewhere.</a:t>
+            </a:r>
+          </a:p>
+          <a:p>
+            <a:endParaRPr lang="en-GB"/>
+          </a:p>
+          <a:p>
+            <a:r>
+              <a:rPr lang="en-GB"/>
+              <a:t>Participant file — what participants complete:</a:t>
+            </a:r>
+          </a:p>
+          <a:p>
+            <a:r>
+              <a:rPr lang="en-GB"/>
+              <a:t>- ✎ Reflection — Your Lever — the primary lever and the second lever they would pull for the clog they identified in Awareness, and why this combination.</a:t>
+            </a:r>
+          </a:p>
+          <a:p>
+            <a:endParaRPr lang="en-GB"/>
+          </a:p>
+          <a:p>
+            <a:r>
+              <a:rPr lang="en-GB"/>
               <a:t>Source detail (S2R® manuscript):</a:t>
             </a:r>
           </a:p>
-          <a:p/>
-          <a:p>
-            <a:r>
+          <a:p>
+            <a:endParaRPr lang="en-GB"/>
+          </a:p>
+          <a:p>
+            <a:r>
+              <a:rPr lang="en-GB"/>
               <a:t>Role of the levers: The levers are not meant to replace the organisational strategy. Friction can come from anywhere: outdated tech, confusing reporting lines, or a lack of trust. Together, the levers allow a leadership team to stop fighting the system and start fine-tuning it.</a:t>
             </a:r>
           </a:p>
           <a:p>
             <a:r>
+              <a:rPr lang="en-GB"/>
               <a:t>How each lever entry reads: Strategic Role; What It Enables; Why This Lever Works.</a:t>
             </a:r>
           </a:p>
           <a:p>
             <a:r>
+              <a:rPr lang="en-GB"/>
               <a:t>02 · Streamline (why it works): This lever is about removing bureaucratic weight.</a:t>
             </a:r>
           </a:p>
           <a:p>
             <a:r>
+              <a:rPr lang="en-GB"/>
               <a:t>05 · Reinforce (in the Capability Gap example): the team’s skills are reinforced through training.</a:t>
             </a:r>
           </a:p>
-          <a:p/>
-          <a:p>
-            <a:r>
+          <a:p>
+            <a:endParaRPr lang="en-GB"/>
+          </a:p>
+          <a:p>
+            <a:r>
+              <a:rPr lang="en-GB"/>
               <a:t>Professional insights:</a:t>
             </a:r>
           </a:p>
-          <a:p/>
-          <a:p>
-            <a:r>
+          <a:p>
+            <a:endParaRPr lang="en-GB"/>
+          </a:p>
+          <a:p>
+            <a:r>
+              <a:rPr lang="en-GB"/>
               <a:t>02 · Streamline: Drift sets in when accumulated processes, activities and traditions become more important than the value they were meant to serve. Protect the core from the additions that obscure it.</a:t>
             </a:r>
           </a:p>
           <a:p>
             <a:r>
+              <a:rPr lang="en-GB"/>
               <a:t>Source: Journal, 25 September 2026 — Professional Insights: Strategy</a:t>
             </a:r>
           </a:p>
-          <a:p/>
-          <a:p>
-            <a:r>
+          <a:p>
+            <a:endParaRPr lang="en-GB"/>
+          </a:p>
+          <a:p>
+            <a:r>
+              <a:rPr lang="en-GB"/>
               <a:t>04 · Upgrade: Leaders who remain at the centre of every decision create dependency, slow decision-making and limited growth in others. Place responsibility close to the people who hold the knowledge and authority to carry it.</a:t>
             </a:r>
           </a:p>
           <a:p>
             <a:r>
+              <a:rPr lang="en-GB"/>
               <a:t>Source: Journal, 10 July 2026 — Professional Insights: Leadership</a:t>
             </a:r>
           </a:p>
-          <a:p/>
-          <a:p>
-            <a:r>
+          <a:p>
+            <a:endParaRPr lang="en-GB"/>
+          </a:p>
+          <a:p>
+            <a:r>
+              <a:rPr lang="en-GB"/>
               <a:t>Mechanisms for action: Organisations often stay frustrated because they announce priorities without creating the mechanisms through which people can act on them. A practical mechanism converts intention into measurable progress.</a:t>
             </a:r>
           </a:p>
           <a:p>
             <a:r>
+              <a:rPr lang="en-GB"/>
               <a:t>Source: Journal, 21 July 2026 — Professional Insights: Strategy</a:t>
             </a:r>
           </a:p>
@@ -2151,7 +2987,7 @@
           <a:p>
             <a:r>
               <a:rPr lang="en-GB"/>
-              <a:t>The leadership team follows a consistent path: REVIEW the performance evidence and confirm the clog; REALIGN executive ownership and the changes required across people and organisational performance; RESTORE by activating the relevant Seven Unclogging Lever and verifying recovery. Review–Realign–Restore is the cycle every performance review follows. Here the executive team applies it together to a clog that crosses executive portfolios.</a:t>
+              <a:t>The leadership team follows a consistent path: REVIEW the performance evidence and confirm the clog; REALIGN executive ownership and the changes required across people and organisational performance; RESTORE by activating the relevant Seven Unclogging Lever and verifying recovery. Review–Realign–Restore is the cycle every performance review follows. Here the executive team applies it together, as the Unclogging Cycle, to a clog that crosses executive portfolios.</a:t>
             </a:r>
           </a:p>
           <a:p>
@@ -2244,7 +3080,7 @@
           <a:p>
             <a:r>
               <a:rPr lang="en-GB"/>
-              <a:t>4.2 — REVIEW: ESTABLISH THE PERFORMANCE REALITY</a:t>
+              <a:t>4.2 — THE UNCLOGGING CYCLE: REVIEW–REALIGN–RESTORE · REVIEW</a:t>
             </a:r>
           </a:p>
           <a:p>
@@ -2259,13 +3095,7 @@
           <a:p>
             <a:r>
               <a:rPr lang="en-GB"/>
-              <a:t>Teach REVIEW as a shared, evidence-based view of the result falling short and the organisational condition behind it, built on the three lines of sight.</a:t>
-            </a:r>
-          </a:p>
-          <a:p>
-            <a:r>
-              <a:rPr lang="en-GB"/>
-              <a:t>Teach the "see something, say something" principle here: the review conversation lets leaders surface friction across functional boundaries, through observable evidence, including where the condition sits in another executive portfolio.</a:t>
+              <a:t>Teach REVIEW as one stage of the Unclogging Cycle: what the stage establishes, what it means in people performance and in organisational performance, and what it adds to the Unclogging Record.</a:t>
             </a:r>
           </a:p>
           <a:p>
@@ -2280,6 +3110,12 @@
           <a:p>
             <a:r>
               <a:rPr lang="en-GB"/>
+              <a:t>The Unclogging Cycle is the S2R® discipline the executive team follows to remove a clog. REVIEW establishes the performance reality and confirms the clog. REALIGN settles which leaders act and what must change. RESTORE activates the Unclogging Lever and verifies recovery. Each stage completes one part of the Unclogging Record, so the record the team holds at the end is the evidence of the whole cycle.</a:t>
+            </a:r>
+          </a:p>
+          <a:p>
+            <a:r>
+              <a:rPr lang="en-GB"/>
               <a:t>REVIEW establishes a shared, evidence-based understanding of the result falling short and the organisational condition contributing to it. Leaders use the Three Performance Lines of Sight to distinguish the outcome from the behaviours observed and the conditions causing or reinforcing them.</a:t>
             </a:r>
           </a:p>
@@ -2310,7 +3146,37 @@
           <a:p>
             <a:r>
               <a:rPr lang="en-GB"/>
+              <a:t>People performance</a:t>
+            </a:r>
+          </a:p>
+          <a:p>
+            <a:r>
+              <a:rPr lang="en-GB"/>
+              <a:t>REVIEW examines what individuals and teams are doing, delaying or unable to do, and separates what is within their control from what the conditions impose. Leaders draw the evidence from the work itself: decisions waiting, hand-offs repeated, rework recorded.</a:t>
+            </a:r>
+          </a:p>
+          <a:p>
+            <a:r>
+              <a:rPr lang="en-GB"/>
+              <a:t>Organisational performance</a:t>
+            </a:r>
+          </a:p>
+          <a:p>
+            <a:r>
+              <a:rPr lang="en-GB"/>
+              <a:t>REVIEW tests whether the organisational conditions support the execution of the individuals’ tasks, and locates the condition sustaining the behaviour. Leaders examine the evidence across executive portfolios, because the condition often sits outside the function where the clog shows.</a:t>
+            </a:r>
+          </a:p>
+          <a:p>
+            <a:r>
+              <a:rPr lang="en-GB"/>
               <a:t>REVIEW is complete when the executive team agrees on the performance gap, the supporting evidence and the clog requiring intervention.</a:t>
+            </a:r>
+          </a:p>
+          <a:p>
+            <a:r>
+              <a:rPr lang="en-GB"/>
+              <a:t>Into the Unclogging Record: the performance gap, the evidence from the three lines of sight and the confirmed clog.</a:t>
             </a:r>
           </a:p>
           <a:p>
@@ -2433,7 +3299,7 @@
           <a:p>
             <a:r>
               <a:rPr lang="en-GB"/>
-              <a:t>4.3 — REALIGN: ESTABLISH COLLECTIVE EXECUTIVE OWNERSHIP</a:t>
+              <a:t>4.2 — THE UNCLOGGING CYCLE: REVIEW–REALIGN–RESTORE · REALIGN</a:t>
             </a:r>
           </a:p>
           <a:p>
@@ -2448,13 +3314,7 @@
           <a:p>
             <a:r>
               <a:rPr lang="en-GB"/>
-              <a:t>Teach the three leadership decisions in order. Then take the group to both dimensions of performance before the response is final: what must change for the people delivering, and what must change in structures, processes, systems, resources, decision rights or governance.</a:t>
-            </a:r>
-          </a:p>
-          <a:p>
-            <a:r>
-              <a:rPr lang="en-GB"/>
-              <a:t>Close on clear individual accountability inside collective ownership: one leader coordinates, the other executives stay accountable for their agreed contributions.</a:t>
+              <a:t>Teach REALIGN as one stage of the Unclogging Cycle: what the stage establishes, what it means in people performance and in organisational performance, and what it adds to the Unclogging Record.</a:t>
             </a:r>
           </a:p>
           <a:p>
@@ -2517,6 +3377,12 @@
           <a:p>
             <a:r>
               <a:rPr lang="en-GB"/>
+              <a:t>The answer becomes the commitments made to the people delivering the result: the authority they receive, the support they are given and what is expected of them.</a:t>
+            </a:r>
+          </a:p>
+          <a:p>
+            <a:r>
+              <a:rPr lang="en-GB"/>
               <a:t>Organisational performance</a:t>
             </a:r>
           </a:p>
@@ -2529,6 +3395,12 @@
           <a:p>
             <a:r>
               <a:rPr lang="en-GB"/>
+              <a:t>The answer becomes the organisational change the executives agree, with the leader responsible for each part.</a:t>
+            </a:r>
+          </a:p>
+          <a:p>
+            <a:r>
+              <a:rPr lang="en-GB"/>
               <a:t>The agreed intervention should address the confirmed organisational condition while enabling the people responsible for delivery to perform effectively.</a:t>
             </a:r>
           </a:p>
@@ -2542,6 +3414,12 @@
             <a:r>
               <a:rPr lang="en-GB"/>
               <a:t>REALIGN is complete when the relevant leaders have agreed what must change, who will act and what each executive must deliver.</a:t>
+            </a:r>
+          </a:p>
+          <a:p>
+            <a:r>
+              <a:rPr lang="en-GB"/>
+              <a:t>Into the Unclogging Record: the coordinating executive, the contributing executives and the agreed changes for people and organisational performance.</a:t>
             </a:r>
           </a:p>
         </p:txBody>
@@ -2685,7 +3563,7 @@
           <a:p>
             <a:r>
               <a:rPr lang="en-GB"/>
-              <a:t>1. Each group selects one challenge from the list it documented before CESI began and links it to a strategic result (5.1).</a:t>
+              <a:t>1. Each group selects one challenge from its Problem Charter and links it to one of its Objectives and Key Results (5.1).</a:t>
             </a:r>
           </a:p>
           <a:p>
@@ -2697,7 +3575,7 @@
           <a:p>
             <a:r>
               <a:rPr lang="en-GB"/>
-              <a:t>3. The group applies Review–Realign–Restore (5.4), then tests its response against the Diagnostic Quality Check (5.5).</a:t>
+              <a:t>3. The group simulates the Unclogging Cycle, Review–Realign–Restore (5.4), then tests its response against the Diagnostic Quality Check (5.5).</a:t>
             </a:r>
           </a:p>
           <a:p>
@@ -2904,7 +3782,7 @@
           <a:p>
             <a:r>
               <a:rPr lang="en-GB"/>
-              <a:t>Each group returns to the organisational challenges its members documented before CESI began, and selects one that is still relevant to its Capstone organisation and clearly linked to disappointing results.</a:t>
+              <a:t>Each group returns to the challenges in its Problem Charter, and selects one that is still relevant to its Capstone organisation and clearly linked to disappointing results.</a:t>
             </a:r>
           </a:p>
           <a:p>
@@ -2925,7 +3803,7 @@
           <a:p>
             <a:r>
               <a:rPr lang="en-GB"/>
-              <a:t>Each group reviews the organisational challenges it documented before CESI began and selects one challenge that remains relevant to its Capstone organisation and has a clear connection to disappointing organisational results.</a:t>
+              <a:t>Each group selects one challenge from its Problem Charter that remains relevant to its Capstone organisation and has a clear connection to disappointing organisational results.</a:t>
             </a:r>
           </a:p>
           <a:p>
@@ -2937,13 +3815,13 @@
           <a:p>
             <a:r>
               <a:rPr lang="en-GB"/>
-              <a:t>Selected original challengeState the challenge as the group originally understood it.</a:t>
-            </a:r>
-          </a:p>
-          <a:p>
-            <a:r>
-              <a:rPr lang="en-GB"/>
-              <a:t>Strategic connectionWhich strategic Objective and Key Result or KPI developed during CESI does this challenge affect?</a:t>
+              <a:t>Selected original challengeThe group selects the challenge from its Problem Charter.</a:t>
+            </a:r>
+          </a:p>
+          <a:p>
+            <a:r>
+              <a:rPr lang="en-GB"/>
+              <a:t>Strategic connectionThe group selects the strategic Objective and Key Result the challenge affects.</a:t>
             </a:r>
           </a:p>
           <a:p>
@@ -3036,7 +3914,7 @@
           <a:p>
             <a:r>
               <a:rPr lang="en-GB"/>
-              <a:t>5.4 — APPLY REVIEW–REALIGN–RESTORE (Capstone Work)</a:t>
+              <a:t>5.4 — SIMULATE THE UNCLOGGING CYCLE (Capstone Work)</a:t>
             </a:r>
           </a:p>
           <a:p>
@@ -3046,6 +3924,12 @@
             <a:r>
               <a:rPr lang="en-GB"/>
               <a:t>TEACHING NOTES:</a:t>
+            </a:r>
+          </a:p>
+          <a:p>
+            <a:r>
+              <a:rPr lang="en-GB"/>
+              <a:t>The group simulates how its executive team takes the selected challenge through the Unclogging Cycle, working through REVIEW, REALIGN and RESTORE in turn. Together they complete the group’s Strategic Unclogging Clinic Record.</a:t>
             </a:r>
           </a:p>
           <a:p>
@@ -3256,6 +4140,277 @@
         <p14:creationId xmlns:p14="http://schemas.microsoft.com/office/powerpoint/2010/main" val="1024086991"/>
       </p:ext>
     </p:extLst>
+  </p:cSld>
+  <p:clrMapOvr>
+    <a:masterClrMapping/>
+  </p:clrMapOvr>
+</p:notes>
+</file>
+
+<file path=ppt/notesSlides/notesSlide22.xml><?xml version="1.0" encoding="utf-8"?>
+<p:notes xmlns:a="http://schemas.openxmlformats.org/drawingml/2006/main" xmlns:p="http://schemas.openxmlformats.org/presentationml/2006/main" xmlns:r="http://schemas.openxmlformats.org/officeDocument/2006/relationships">
+  <p:cSld>
+    <p:spTree>
+      <p:nvGrpSpPr>
+        <p:cNvPr id="1" name=""/>
+        <p:cNvGrpSpPr/>
+        <p:nvPr/>
+      </p:nvGrpSpPr>
+      <p:grpSpPr>
+        <a:xfrm>
+          <a:off x="0" y="0"/>
+          <a:ext cx="0" cy="0"/>
+          <a:chOff x="0" y="0"/>
+          <a:chExt cx="0" cy="0"/>
+        </a:xfrm>
+      </p:grpSpPr>
+      <p:sp>
+        <p:nvSpPr>
+          <p:cNvPr id="2" name="Slide Image Placeholder 1"/>
+          <p:cNvSpPr>
+            <a:spLocks noGrp="1" noRot="1" noChangeAspect="1"/>
+          </p:cNvSpPr>
+          <p:nvPr>
+            <p:ph type="sldImg"/>
+          </p:nvPr>
+        </p:nvSpPr>
+        <p:spPr/>
+      </p:sp>
+      <p:sp>
+        <p:nvSpPr>
+          <p:cNvPr id="3" name="Notes Placeholder 2"/>
+          <p:cNvSpPr>
+            <a:spLocks noGrp="1"/>
+          </p:cNvSpPr>
+          <p:nvPr>
+            <p:ph type="body" idx="1"/>
+          </p:nvPr>
+        </p:nvSpPr>
+        <p:spPr/>
+        <p:txBody>
+          <a:bodyPr/>
+          <a:lstStyle/>
+          <a:p>
+            <a:r>
+              <a:rPr lang="en-GB"/>
+              <a:t>1.5 — WORKED DIAGNOSTIC EXAMPLE: IMPROVING CUSTOMER SERVICE (Tracing the three lines of sight)</a:t>
+            </a:r>
+          </a:p>
+          <a:p>
+            <a:endParaRPr lang="en-GB"/>
+          </a:p>
+          <a:p>
+            <a:r>
+              <a:rPr lang="en-GB"/>
+              <a:t>TEACHING NOTES:</a:t>
+            </a:r>
+          </a:p>
+          <a:p>
+            <a:r>
+              <a:rPr lang="en-GB"/>
+              <a:t>1.5 · Work through the worked example and the Closing Diagnostic Principle. Participants complete the self-assessment in their own file.</a:t>
+            </a:r>
+          </a:p>
+          <a:p>
+            <a:endParaRPr lang="en-GB"/>
+          </a:p>
+          <a:p>
+            <a:r>
+              <a:rPr lang="en-GB"/>
+              <a:t>Content:</a:t>
+            </a:r>
+          </a:p>
+          <a:p>
+            <a:r>
+              <a:rPr lang="en-GB"/>
+              <a:t>Enterprise Objective. Deliver a reliable and responsive customer service experience.</a:t>
+            </a:r>
+          </a:p>
+          <a:p>
+            <a:r>
+              <a:rPr lang="en-GB"/>
+              <a:t>Enterprise Key Result. Increase customer enquiries resolved within 48 hours from 65% to 90% by year-end.</a:t>
+            </a:r>
+          </a:p>
+          <a:p>
+            <a:r>
+              <a:rPr lang="en-GB"/>
+              <a:t>Performance figures are illustrative.</a:t>
+            </a:r>
+          </a:p>
+          <a:p>
+            <a:r>
+              <a:rPr lang="en-GB"/>
+              <a:t>Line of Sight 1 — Performance Outcome</a:t>
+            </a:r>
+          </a:p>
+          <a:p>
+            <a:r>
+              <a:rPr lang="en-GB"/>
+              <a:t>Only 65% of customer enquiries are resolved within 48 hours against a target of 90%. The enterprise is falling short of its intended customer responsiveness and service reliability.</a:t>
+            </a:r>
+          </a:p>
+          <a:p>
+            <a:r>
+              <a:rPr lang="en-GB"/>
+              <a:t>Line of Sight 2 — Performance Behaviour</a:t>
+            </a:r>
+          </a:p>
+          <a:p>
+            <a:r>
+              <a:rPr lang="en-GB"/>
+              <a:t>Service agents process enquiries and escalate cases requiring other departments. Cases are frequently transferred without end-to-end ownership, managers wait for approval on routine refunds, and staff spend their time requesting updates while customer problems wait. Employees may be achieving their activity targets while the collective resolution outcome remains weak.</a:t>
+            </a:r>
+          </a:p>
+          <a:p>
+            <a:r>
+              <a:rPr lang="en-GB"/>
+              <a:t>Line of Sight 3 — Performance Condition</a:t>
+            </a:r>
+          </a:p>
+          <a:p>
+            <a:r>
+              <a:rPr lang="en-GB"/>
+              <a:t>The diagnostic identifies the organisational conditions that help explain the behaviour:</a:t>
+            </a:r>
+          </a:p>
+          <a:p>
+            <a:r>
+              <a:rPr lang="en-GB"/>
+              <a:t>Evidence · Clog · How it constrains performance</a:t>
+            </a:r>
+          </a:p>
+          <a:p>
+            <a:r>
+              <a:rPr lang="en-GB"/>
+              <a:t>40% of delayed cases require another department. · Structural Misfit · Fragmented ownership and weak cross-functional handoffs delay resolution.</a:t>
+            </a:r>
+          </a:p>
+          <a:p>
+            <a:r>
+              <a:rPr lang="en-GB"/>
+              <a:t>Routine refunds require senior-management approval. · Decision Bottlenecks · People closest to the enquiry lack sufficient authority to resolve it.</a:t>
+            </a:r>
+          </a:p>
+          <a:p>
+            <a:r>
+              <a:rPr lang="en-GB"/>
+              <a:t>Employee scorecards emphasise enquiries processed. · Misaligned Metrics &amp; Incentives · Volume is reinforced more strongly than complete and timely resolution.</a:t>
+            </a:r>
+          </a:p>
+          <a:p>
+            <a:r>
+              <a:rPr lang="en-GB"/>
+              <a:t>Employees cannot track cases after escalation. · Technology / Infrastructure Lag · Fragmented information prevents timely follow-through.</a:t>
+            </a:r>
+          </a:p>
+          <a:p>
+            <a:r>
+              <a:rPr lang="en-GB"/>
+              <a:t>Organisational performance interpretation</a:t>
+            </a:r>
+          </a:p>
+          <a:p>
+            <a:r>
+              <a:rPr lang="en-GB"/>
+              <a:t>The coordination processes, decision rights, measures and information systems are not sufficiently aligned to the customer-resolution outcome. These conditions create recurring delays across the service chain.</a:t>
+            </a:r>
+          </a:p>
+          <a:p>
+            <a:r>
+              <a:rPr lang="en-GB"/>
+              <a:t>People performance interpretation</a:t>
+            </a:r>
+          </a:p>
+          <a:p>
+            <a:r>
+              <a:rPr lang="en-GB"/>
+              <a:t>Customer service employees may complete assigned tasks but still lack the authority, information and cross-functional support needed to resolve cases. Any individual capability or behavioural gaps must be assessed against these conditions and the standards within each person’s control.</a:t>
+            </a:r>
+          </a:p>
+          <a:p>
+            <a:r>
+              <a:rPr lang="en-GB"/>
+              <a:t>Strategic interpretation</a:t>
+            </a:r>
+          </a:p>
+          <a:p>
+            <a:r>
+              <a:rPr lang="en-GB"/>
+              <a:t>The customer value proposition promises responsive service, but operating arrangements do not consistently enable its delivery. The principal ABCV distortion concerns the Value Proposition, with contributing constraints in Boundaries and Competition.</a:t>
+            </a:r>
+          </a:p>
+          <a:p>
+            <a:r>
+              <a:rPr lang="en-GB"/>
+              <a:t>Required management response</a:t>
+            </a:r>
+          </a:p>
+          <a:p>
+            <a:r>
+              <a:rPr lang="en-GB"/>
+              <a:t>Clarify end-to-end resolution ownership, adjust routine decision authority, align measures to resolution outcomes and improve case visibility across departments. Provide coaching or accountability interventions where evidence confirms individual capability or behavioural gaps.</a:t>
+            </a:r>
+          </a:p>
+          <a:p>
+            <a:r>
+              <a:rPr lang="en-GB"/>
+              <a:t>Closing Diagnostic Principle</a:t>
+            </a:r>
+          </a:p>
+          <a:p>
+            <a:r>
+              <a:rPr lang="en-GB"/>
+              <a:t>Performance is produced through people operating within an organisational system. A sound diagnosis examines the result, the behaviours shaping contributions and the organisational conditions that enable or constrain them.</a:t>
+            </a:r>
+          </a:p>
+          <a:p>
+            <a:r>
+              <a:rPr lang="en-GB"/>
+              <a:t>The 7-Clog Diagnostic Map helps leaders identify where these relationships have become misaligned, which ABCV elements are affected and what must change to restore performance.</a:t>
+            </a:r>
+          </a:p>
+          <a:p>
+            <a:endParaRPr lang="en-GB"/>
+          </a:p>
+          <a:p>
+            <a:r>
+              <a:rPr lang="en-GB"/>
+              <a:t>Participant file — what participants complete:</a:t>
+            </a:r>
+          </a:p>
+          <a:p>
+            <a:r>
+              <a:rPr lang="en-GB"/>
+              <a:t>- ✎ Reflection — Which Clogs Are Active? — a rating of each of the seven clogs, and the clog most active in their organisation with the organisational condition it sits in.</a:t>
+            </a:r>
+          </a:p>
+        </p:txBody>
+      </p:sp>
+      <p:sp>
+        <p:nvSpPr>
+          <p:cNvPr id="4" name="Slide Number Placeholder 3"/>
+          <p:cNvSpPr>
+            <a:spLocks noGrp="1"/>
+          </p:cNvSpPr>
+          <p:nvPr>
+            <p:ph type="sldNum" sz="quarter" idx="10"/>
+          </p:nvPr>
+        </p:nvSpPr>
+        <p:spPr/>
+        <p:txBody>
+          <a:bodyPr/>
+          <a:lstStyle/>
+          <a:p>
+            <a:fld id="{F7021451-1387-4CA6-816F-3879F97B5CBC}" type="slidenum">
+              <a:rPr lang="en-US"/>
+              <a:t>21</a:t>
+            </a:fld>
+            <a:endParaRPr lang="en-US"/>
+          </a:p>
+        </p:txBody>
+      </p:sp>
+    </p:spTree>
   </p:cSld>
   <p:clrMapOvr>
     <a:masterClrMapping/>
@@ -3507,7 +4662,7 @@
           <a:p>
             <a:r>
               <a:rPr lang="en-GB"/>
-              <a:t>1. The original work-based challenge selected from its pre-CESI preparation.</a:t>
+              <a:t>1. The original work-based challenge selected from its Problem Charter.</a:t>
             </a:r>
           </a:p>
           <a:p>
@@ -3639,7 +4794,7 @@
           <a:p>
             <a:r>
               <a:rPr lang="en-GB"/>
-              <a:t>A Strategic Clog is an internal blockage that prevents strategic intent from flowing into execution. Performance has two connected dimensions, organisational performance and people performance. The 7-Clog Diagnostic Map, aligned to ABCV Directional Integrity, examines both, and the Three Performance Lines of Sight trace a result from its outcome to the behaviours and the conditions behind it.</a:t>
+              <a:t>A Strategic Clog is an internal blockage that prevents strategic intent from flowing into execution. Clogs form where the strategy stretches today’s organisation. Performance has two connected dimensions, organisational performance and people performance. The 7-Clog Diagnostic Map, aligned to ABCV Directional Integrity, examines both, and the Three Performance Lines of Sight trace a result from its outcome to the behaviours and the conditions behind it.</a:t>
             </a:r>
           </a:p>
           <a:p>
@@ -3651,7 +4806,7 @@
           <a:p>
             <a:r>
               <a:rPr lang="en-GB"/>
-              <a:t>Clogs are design signals. Where strategy stretches the operating system beyond its current capacity, friction will appear predictably. The three disciplines of execution engineering (identify, classify, intervene) and the 7 levers restore flow without reactive pressure.</a:t>
+              <a:t>Leaders resolve clogs through three disciplines: early identification, accurate classification and targeted intervention. The 7 Strategic Unclogging Levers act on people performance and organisational performance together.</a:t>
             </a:r>
           </a:p>
           <a:p>
@@ -3675,7 +4830,7 @@
           <a:p>
             <a:r>
               <a:rPr lang="en-GB"/>
-              <a:t>Clogs rarely stay in one lane. The leadership team removes them together through Review–Realign–Restore: REVIEW confirms the clog, REALIGN agrees collective ownership and the changes for people and organisational performance, and RESTORE activates the Unclogging Lever and verifies recovery.</a:t>
+              <a:t>Clogs rarely stay in one lane. The leadership team removes them together through the Unclogging Cycle: REVIEW confirms the clog, REALIGN agrees collective ownership and the changes for people and organisational performance, and RESTORE activates the Unclogging Lever and verifies recovery. Each stage completes part of the Unclogging Record.</a:t>
             </a:r>
           </a:p>
           <a:p>
@@ -3687,7 +4842,7 @@
           <a:p>
             <a:r>
               <a:rPr lang="en-GB"/>
-              <a:t>Each group returned to an original work-based challenge, identified the clog, selected the lever and applied Review–Realign–Restore within its Capstone organisation. The confirmed record feeds the team’s Capstone Blueprint.</a:t>
+              <a:t>Each group selected a challenge from its Problem Charter, identified the clog, selected the lever and simulated the Unclogging Cycle within its Capstone organisation. The agreed record feeds the team’s Capstone Blueprint.</a:t>
             </a:r>
           </a:p>
           <a:p>
@@ -3828,7 +4983,7 @@
           <a:p>
             <a:r>
               <a:rPr lang="en-GB"/>
-              <a:t>1.2.2 — THE THREE PERFORMANCE LINES OF SIGHT</a:t>
+              <a:t>1.4 — THE THREE PERFORMANCE LINES OF SIGHT FROM THE SEVEN CLOGS (From the result to its cause)</a:t>
             </a:r>
           </a:p>
           <a:p>
@@ -3843,19 +4998,88 @@
           <a:p>
             <a:r>
               <a:rPr lang="en-GB"/>
-              <a:t>Teach the three levels of performance evidence in order. The outcome names the result falling short and the size of the gap. The behaviour names what individuals and teams are doing, or unable to do. The condition names the organisational arrangement, capability, incentive or leadership practice behind that behaviour; the seven clogs are tested here.</a:t>
-            </a:r>
-          </a:p>
-          <a:p>
-            <a:r>
-              <a:rPr lang="en-GB"/>
-              <a:t>Land the reason for the discipline: it keeps leaders from treating every disappointing result as an individual performance failure, and it keeps people accountable for what is within their control.</a:t>
-            </a:r>
-          </a:p>
-          <a:p>
-            <a:r>
-              <a:rPr lang="en-GB"/>
-              <a:t>Walk the customer service example of 1.2.3: 65% of enquiries resolved within 48 hours against 90%; cases transferred without end-to-end ownership; four clogs in the evidence table; the organisational, people and strategic interpretations; the management response.</a:t>
+              <a:t>1.4 · Teach the Three Performance Lines of Sight.</a:t>
+            </a:r>
+          </a:p>
+          <a:p>
+            <a:endParaRPr lang="en-GB"/>
+          </a:p>
+          <a:p>
+            <a:r>
+              <a:rPr lang="en-GB"/>
+              <a:t>Content:</a:t>
+            </a:r>
+          </a:p>
+          <a:p>
+            <a:r>
+              <a:rPr lang="en-GB"/>
+              <a:t>The central discipline is to distinguish three levels of performance evidence. Each line of sight reveals a different part of the performance problem and helps leaders move from symptoms to causes.</a:t>
+            </a:r>
+          </a:p>
+          <a:p>
+            <a:r>
+              <a:rPr lang="en-GB"/>
+              <a:t>1</a:t>
+            </a:r>
+          </a:p>
+          <a:p>
+            <a:r>
+              <a:rPr lang="en-GB"/>
+              <a:t>Performance outcome</a:t>
+            </a:r>
+          </a:p>
+          <a:p>
+            <a:r>
+              <a:rPr lang="en-GB"/>
+              <a:t>What result is falling short? Establish the intended strategic outcome, the actual result and the size or nature of the gap.</a:t>
+            </a:r>
+          </a:p>
+          <a:p>
+            <a:r>
+              <a:rPr lang="en-GB"/>
+              <a:t>2</a:t>
+            </a:r>
+          </a:p>
+          <a:p>
+            <a:r>
+              <a:rPr lang="en-GB"/>
+              <a:t>Performance behaviour</a:t>
+            </a:r>
+          </a:p>
+          <a:p>
+            <a:r>
+              <a:rPr lang="en-GB"/>
+              <a:t>What are people or teams doing, or unable to do, that contributes to the gap? Observe specific decisions, actions, omissions, collaboration patterns and delivery practices.</a:t>
+            </a:r>
+          </a:p>
+          <a:p>
+            <a:r>
+              <a:rPr lang="en-GB"/>
+              <a:t>3</a:t>
+            </a:r>
+          </a:p>
+          <a:p>
+            <a:r>
+              <a:rPr lang="en-GB"/>
+              <a:t>Performance condition</a:t>
+            </a:r>
+          </a:p>
+          <a:p>
+            <a:r>
+              <a:rPr lang="en-GB"/>
+              <a:t>What organisational arrangements, capabilities, incentives or leadership practices are causing or reinforcing that behaviour? Test the seven clogs to explain why the pattern persists.</a:t>
+            </a:r>
+          </a:p>
+          <a:p>
+            <a:r>
+              <a:rPr lang="en-GB"/>
+              <a:t>This distinction helps leaders avoid treating every disappointing result as an individual performance failure. It also keeps people accountable for actions within their control while recognising the organisation’s responsibility for enabling conditions.</a:t>
+            </a:r>
+          </a:p>
+          <a:p>
+            <a:r>
+              <a:rPr lang="en-GB"/>
+              <a:t>A single performance outcome can reflect several interacting clogs. The following example traces the three lines of sight before identifying the organisational conditions that require attention.</a:t>
             </a:r>
           </a:p>
         </p:txBody>
@@ -3937,7 +5161,7 @@
           <a:p>
             <a:r>
               <a:rPr lang="en-GB"/>
-              <a:t>4.4 — RESTORE: ACTIVATE THE SEVEN UNCLOGGING LEVERS</a:t>
+              <a:t>4.2 — THE UNCLOGGING CYCLE: REVIEW–REALIGN–RESTORE · RESTORE</a:t>
             </a:r>
           </a:p>
           <a:p>
@@ -3952,19 +5176,7 @@
           <a:p>
             <a:r>
               <a:rPr lang="en-GB"/>
-              <a:t>Teach RESTORE as the step that turns the agreed response into organisational action: select the lever, activate the intervention, verify recovery.</a:t>
-            </a:r>
-          </a:p>
-          <a:p>
-            <a:r>
-              <a:rPr lang="en-GB"/>
-              <a:t>Distinguish the REALIGN stage of S2R® (the collective decision and ownership step) from Lever 06 · Realign (the intervention that adjusts metrics and rewards).</a:t>
-            </a:r>
-          </a:p>
-          <a:p>
-            <a:r>
-              <a:rPr lang="en-GB"/>
-              <a:t>Land the closing line: removing a clog requires evidence that the organisational condition has changed, verified through the normal performance review rhythm.</a:t>
+              <a:t>Teach RESTORE as one stage of the Unclogging Cycle: what the stage establishes, what it means in people performance and in organisational performance, and what it adds to the Unclogging Record.</a:t>
             </a:r>
           </a:p>
           <a:p>
@@ -4058,6 +5270,72 @@
             <a:r>
               <a:rPr lang="en-GB"/>
               <a:t>Removing a clog requires evidence that the organisational condition has changed. Sustained improvement is verified through the normal performance review rhythm.</a:t>
+            </a:r>
+          </a:p>
+          <a:p>
+            <a:r>
+              <a:rPr lang="en-GB"/>
+              <a:t>People performance</a:t>
+            </a:r>
+          </a:p>
+          <a:p>
+            <a:r>
+              <a:rPr lang="en-GB"/>
+              <a:t>RESTORE equips individuals to deliver under the changed conditions and verifies the change in their work: decisions taken at the right level, delays falling, rework reducing and problems raised early.</a:t>
+            </a:r>
+          </a:p>
+          <a:p>
+            <a:r>
+              <a:rPr lang="en-GB"/>
+              <a:t>Organisational performance</a:t>
+            </a:r>
+          </a:p>
+          <a:p>
+            <a:r>
+              <a:rPr lang="en-GB"/>
+              <a:t>RESTORE applies the lever to the organisational condition and verifies that the condition has changed: the approval route, the data source, the decision right or the measure now supports the execution of the individuals’ tasks, and the Key Result begins to move.</a:t>
+            </a:r>
+          </a:p>
+          <a:p>
+            <a:r>
+              <a:rPr lang="en-GB"/>
+              <a:t>Into the Unclogging Record: the selected lever, the actions with their owners and completion dates, the evidence of recovery and the date of the next review.</a:t>
+            </a:r>
+          </a:p>
+          <a:p>
+            <a:r>
+              <a:rPr lang="en-GB"/>
+              <a:t>The Unclogging Record holds the outcome of each stage in one place. The executive team completes it as it moves through the cycle, then uses it at each later review to check that the agreed actions are complete and the evidence is moving.</a:t>
+            </a:r>
+          </a:p>
+          <a:p>
+            <a:r>
+              <a:rPr lang="en-GB"/>
+              <a:t>Stage · What the record holds</a:t>
+            </a:r>
+          </a:p>
+          <a:p>
+            <a:r>
+              <a:rPr lang="en-GB"/>
+              <a:t>REVIEW · The performance gap, the evidence from the three lines of sight and the confirmed clog.</a:t>
+            </a:r>
+          </a:p>
+          <a:p>
+            <a:r>
+              <a:rPr lang="en-GB"/>
+              <a:t>REALIGN · The coordinating executive, the contributing executives and the agreed changes for people and organisational performance.</a:t>
+            </a:r>
+          </a:p>
+          <a:p>
+            <a:r>
+              <a:rPr lang="en-GB"/>
+              <a:t>RESTORE · The selected lever, the actions with their owners and completion dates, the evidence of recovery and the date of the next review.</a:t>
+            </a:r>
+          </a:p>
+          <a:p>
+            <a:r>
+              <a:rPr lang="en-GB"/>
+              <a:t>The worked example in 4.3 ends with a completed Unclogging Record.</a:t>
             </a:r>
           </a:p>
         </p:txBody>
@@ -4139,7 +5417,7 @@
           <a:p>
             <a:r>
               <a:rPr lang="en-GB"/>
-              <a:t>4.5 — WORKED EXAMPLE: REVIEW–REALIGN–RESTORE (A manufacturing case)</a:t>
+              <a:t>4.3 — WORKED EXAMPLE: THE UNCLOGGING CYCLE (A manufacturing case)</a:t>
             </a:r>
           </a:p>
           <a:p>
@@ -5027,7 +6305,13 @@
           <a:p>
             <a:r>
               <a:rPr lang="en-GB"/>
-              <a:t>1.2 · Which Clogs Are Active?: a rating of each of the seven clogs, and the clog most active in their organisation with the organisational condition it sits in.</a:t>
+              <a:t>1.2 · Where Is Your System Not Yet Ready?: the element of their operating system most likely to create friction under their current strategic direction, and why.</a:t>
+            </a:r>
+          </a:p>
+          <a:p>
+            <a:r>
+              <a:rPr lang="en-GB"/>
+              <a:t>1.5 · Which Clogs Are Active?: a rating of each of the seven clogs, and the clog most active in their organisation with the organisational condition it sits in.</a:t>
             </a:r>
           </a:p>
         </p:txBody>
@@ -5118,19 +6402,13 @@
           <a:p>
             <a:r>
               <a:rPr lang="en-GB"/>
-              <a:t>Participants complete these reflections in their own file after the teaching.</a:t>
-            </a:r>
-          </a:p>
-          <a:p>
-            <a:r>
-              <a:rPr lang="en-GB"/>
-              <a:t>2.1 · Where Is Your System Not Yet Ready?: the element of their operating system most likely to create friction under their current strategic direction, and why.</a:t>
-            </a:r>
-          </a:p>
-          <a:p>
-            <a:r>
-              <a:rPr lang="en-GB"/>
-              <a:t>2.3 · Your Lever: the primary lever and the second lever they would pull for the clog they identified in Awareness, and why this combination.</a:t>
+              <a:t>Participants complete this reflection in their own file after the teaching.</a:t>
+            </a:r>
+          </a:p>
+          <a:p>
+            <a:r>
+              <a:rPr lang="en-GB"/>
+              <a:t>2.2 · Your Lever: the primary lever and the second lever they would pull for the clog they identified in Awareness, and why this combination.</a:t>
             </a:r>
           </a:p>
         </p:txBody>
@@ -5886,7 +7164,7 @@
           <a:p>
             <a:r>
               <a:rPr lang="en-GB"/>
-              <a:t>1.2 — THE 7-CLOG DIAGNOSTIC MAP (ABCV-aligned · Select each clog to explore)</a:t>
+              <a:t>1.3 — THE SEVEN PERFORMANCE CLOGS (ABCV-aligned · Select each clog to explore)</a:t>
             </a:r>
           </a:p>
           <a:p>
@@ -5895,78 +7173,27 @@
           <a:p>
             <a:r>
               <a:rPr lang="en-GB"/>
+              <a:t>TEACHING NOTES:</a:t>
+            </a:r>
+          </a:p>
+          <a:p>
+            <a:r>
+              <a:rPr lang="en-GB"/>
+              <a:t>1.3 · Teach the seven clogs one card at a time.</a:t>
+            </a:r>
+          </a:p>
+          <a:p>
+            <a:endParaRPr lang="en-GB"/>
+          </a:p>
+          <a:p>
+            <a:r>
+              <a:rPr lang="en-GB"/>
               <a:t>Content:</a:t>
             </a:r>
           </a:p>
           <a:p>
             <a:r>
               <a:rPr lang="en-GB"/>
-              <a:t>Understanding Where Performance Becomes Constrained</a:t>
-            </a:r>
-          </a:p>
-          <a:p>
-            <a:r>
-              <a:rPr lang="en-GB"/>
-              <a:t>Strategy depends on the organisation’s ability to convert its strategic intent into coordinated contributions and measurable results. This requires two connected dimensions of performance:</a:t>
-            </a:r>
-          </a:p>
-          <a:p>
-            <a:r>
-              <a:rPr lang="en-GB"/>
-              <a:t>Organisational performance</a:t>
-            </a:r>
-          </a:p>
-          <a:p>
-            <a:r>
-              <a:rPr lang="en-GB"/>
-              <a:t>The enterprise’s ability to create, deliver and sustain value. It reflects how effectively structures, processes, resources, capabilities, governance and operating systems work together to produce strategic outcomes.</a:t>
-            </a:r>
-          </a:p>
-          <a:p>
-            <a:r>
-              <a:rPr lang="en-GB"/>
-              <a:t>People performance</a:t>
-            </a:r>
-          </a:p>
-          <a:p>
-            <a:r>
-              <a:rPr lang="en-GB"/>
-              <a:t>How effectively individuals and teams understand expectations, make decisions, exercise judgement, apply capabilities, collaborate and deliver their contributions to organisational results.</a:t>
-            </a:r>
-          </a:p>
-          <a:p>
-            <a:r>
-              <a:rPr lang="en-GB"/>
-              <a:t>Both dimensions operate within the same enterprise system. When organisational conditions are weak, even capable and committed people may struggle to perform. They experience delays, conflicting priorities, unclear responsibilities, resource shortages and barriers beyond their authority to resolve.</a:t>
-            </a:r>
-          </a:p>
-          <a:p>
-            <a:r>
-              <a:rPr lang="en-GB"/>
-              <a:t>When people performance is weak, the organisation may have adequate resources and well-designed processes but still experience poor judgement, inconsistent behaviours, weak collaboration, limited ownership and unreliable delivery.</a:t>
-            </a:r>
-          </a:p>
-          <a:p>
-            <a:r>
-              <a:rPr lang="en-GB"/>
-              <a:t>These conditions often reinforce one another. For example, unclear decision rights create hesitation among managers. Repeated hesitation then encourages senior leaders to centralise decisions further, increasing the original bottleneck.</a:t>
-            </a:r>
-          </a:p>
-          <a:p>
-            <a:r>
-              <a:rPr lang="en-GB"/>
-              <a:t>The 7-Clog Diagnostic Map identifies seven recurring conditions that constrain the organisation’s capacity to deliver its strategy. The diagnostic examines both the condition of the organisational system and the performance patterns emerging within it.</a:t>
-            </a:r>
-          </a:p>
-          <a:p>
-            <a:r>
-              <a:rPr lang="en-GB"/>
-              <a:t>The Seven Performance Clogs</a:t>
-            </a:r>
-          </a:p>
-          <a:p>
-            <a:r>
-              <a:rPr lang="en-GB"/>
               <a:t>Participants select each clog to examine its organisational conditions, effects on people, observable patterns, early warnings and strategic consequences.</a:t>
             </a:r>
           </a:p>
@@ -6892,309 +8119,6 @@
             <a:r>
               <a:rPr lang="en-GB"/>
               <a:t>A management team repeatedly identifies poor coordination between sales and operations but avoids changing responsibilities because two senior executives disagree. The problem continues, and both teams are blamed for missed delivery targets.</a:t>
-            </a:r>
-          </a:p>
-          <a:p>
-            <a:r>
-              <a:rPr lang="en-GB"/>
-              <a:t>1.2.1 — The ABCV Diagnostic Connection</a:t>
-            </a:r>
-          </a:p>
-          <a:p>
-            <a:r>
-              <a:rPr lang="en-GB"/>
-              <a:t>The ABCV framework helps locate the strategic dimension being distorted by a performance clog.</a:t>
-            </a:r>
-          </a:p>
-          <a:p>
-            <a:r>
-              <a:rPr lang="en-GB"/>
-              <a:t>ABCV element · Strategic concern · Related clogs</a:t>
-            </a:r>
-          </a:p>
-          <a:p>
-            <a:r>
-              <a:rPr lang="en-GB"/>
-              <a:t>Arena · Does the organisation have the capability and focus to operate successfully in its chosen strategic space? · Capability Gaps; Leadership Avoidance</a:t>
-            </a:r>
-          </a:p>
-          <a:p>
-            <a:r>
-              <a:rPr lang="en-GB"/>
-              <a:t>Boundaries · Do organisational arrangements, decision rights and governance enable disciplined, coordinated delivery? · Structural Misfit; Decision Bottlenecks; Leadership Avoidance</a:t>
-            </a:r>
-          </a:p>
-          <a:p>
-            <a:r>
-              <a:rPr lang="en-GB"/>
-              <a:t>Competition · Can the enterprise respond and perform at the speed, reliability and standard required in its competitive environment? · Technology / Infrastructure Lag</a:t>
-            </a:r>
-          </a:p>
-          <a:p>
-            <a:r>
-              <a:rPr lang="en-GB"/>
-              <a:t>Value Proposition · Do organisational behaviours, measures and contributions produce the value promised to stakeholders? · Misaligned Metrics &amp; Incentives; Cultural Resistance</a:t>
-            </a:r>
-          </a:p>
-          <a:p>
-            <a:r>
-              <a:rPr lang="en-GB"/>
-              <a:t>These are primary diagnostic associations. A clog may affect several ABCV elements simultaneously. For example, inadequate technology may primarily affect competitive responsiveness but also prevent the organisation from delivering its value proposition. Similarly, a structural misfit may originate in organisational boundaries while undermining the chosen strategic arena.</a:t>
-            </a:r>
-          </a:p>
-          <a:p>
-            <a:r>
-              <a:rPr lang="en-GB"/>
-              <a:t>ABCV helps identify where strategic intent is being distorted; the 7-Clog Diagnostic Map helps explain the conditions producing that distortion.</a:t>
-            </a:r>
-          </a:p>
-          <a:p>
-            <a:r>
-              <a:rPr lang="en-GB"/>
-              <a:t>1.2.2 — The Three Performance Lines of Sight from the Seven Clogs</a:t>
-            </a:r>
-          </a:p>
-          <a:p>
-            <a:r>
-              <a:rPr lang="en-GB"/>
-              <a:t>The central discipline is to distinguish three levels of performance evidence. Each line of sight reveals a different part of the performance problem and helps leaders move from symptoms to causes.</a:t>
-            </a:r>
-          </a:p>
-          <a:p>
-            <a:r>
-              <a:rPr lang="en-GB"/>
-              <a:t>1</a:t>
-            </a:r>
-          </a:p>
-          <a:p>
-            <a:r>
-              <a:rPr lang="en-GB"/>
-              <a:t>Performance outcome</a:t>
-            </a:r>
-          </a:p>
-          <a:p>
-            <a:r>
-              <a:rPr lang="en-GB"/>
-              <a:t>What result is falling short? Establish the intended strategic outcome, the actual result and the size or nature of the gap.</a:t>
-            </a:r>
-          </a:p>
-          <a:p>
-            <a:r>
-              <a:rPr lang="en-GB"/>
-              <a:t>2</a:t>
-            </a:r>
-          </a:p>
-          <a:p>
-            <a:r>
-              <a:rPr lang="en-GB"/>
-              <a:t>Performance behaviour</a:t>
-            </a:r>
-          </a:p>
-          <a:p>
-            <a:r>
-              <a:rPr lang="en-GB"/>
-              <a:t>What are people or teams doing, or unable to do, that contributes to the gap? Observe specific decisions, actions, omissions, collaboration patterns and delivery practices.</a:t>
-            </a:r>
-          </a:p>
-          <a:p>
-            <a:r>
-              <a:rPr lang="en-GB"/>
-              <a:t>3</a:t>
-            </a:r>
-          </a:p>
-          <a:p>
-            <a:r>
-              <a:rPr lang="en-GB"/>
-              <a:t>Performance condition</a:t>
-            </a:r>
-          </a:p>
-          <a:p>
-            <a:r>
-              <a:rPr lang="en-GB"/>
-              <a:t>What organisational arrangements, capabilities, incentives or leadership practices are causing or reinforcing that behaviour? Test the seven clogs to explain why the pattern persists.</a:t>
-            </a:r>
-          </a:p>
-          <a:p>
-            <a:r>
-              <a:rPr lang="en-GB"/>
-              <a:t>This distinction helps leaders avoid treating every disappointing result as an individual performance failure. It also keeps people accountable for actions within their control while recognising the organisation’s responsibility for enabling conditions.</a:t>
-            </a:r>
-          </a:p>
-          <a:p>
-            <a:r>
-              <a:rPr lang="en-GB"/>
-              <a:t>A single performance outcome can reflect several interacting clogs. The following example traces the three lines of sight before identifying the organisational conditions that require attention.</a:t>
-            </a:r>
-          </a:p>
-          <a:p>
-            <a:r>
-              <a:rPr lang="en-GB"/>
-              <a:t>1.2.3 — Worked Diagnostic Example: Improving Customer Service</a:t>
-            </a:r>
-          </a:p>
-          <a:p>
-            <a:r>
-              <a:rPr lang="en-GB"/>
-              <a:t>Enterprise Objective. Deliver a reliable and responsive customer service experience.</a:t>
-            </a:r>
-          </a:p>
-          <a:p>
-            <a:r>
-              <a:rPr lang="en-GB"/>
-              <a:t>Enterprise Key Result. Increase customer enquiries resolved within 48 hours from 65% to 90% by year-end.</a:t>
-            </a:r>
-          </a:p>
-          <a:p>
-            <a:r>
-              <a:rPr lang="en-GB"/>
-              <a:t>Performance figures are illustrative.</a:t>
-            </a:r>
-          </a:p>
-          <a:p>
-            <a:r>
-              <a:rPr lang="en-GB"/>
-              <a:t>Line of Sight 1 — Performance Outcome</a:t>
-            </a:r>
-          </a:p>
-          <a:p>
-            <a:r>
-              <a:rPr lang="en-GB"/>
-              <a:t>Only 65% of customer enquiries are resolved within 48 hours against a target of 90%. The enterprise is falling short of its intended customer responsiveness and service reliability.</a:t>
-            </a:r>
-          </a:p>
-          <a:p>
-            <a:r>
-              <a:rPr lang="en-GB"/>
-              <a:t>Line of Sight 2 — Performance Behaviour</a:t>
-            </a:r>
-          </a:p>
-          <a:p>
-            <a:r>
-              <a:rPr lang="en-GB"/>
-              <a:t>Service agents process enquiries and escalate cases requiring other departments. Cases are frequently transferred without end-to-end ownership, managers wait for approval on routine refunds, and staff spend their time requesting updates while customer problems wait. Employees may be achieving their activity targets while the collective resolution outcome remains weak.</a:t>
-            </a:r>
-          </a:p>
-          <a:p>
-            <a:r>
-              <a:rPr lang="en-GB"/>
-              <a:t>Line of Sight 3 — Performance Condition</a:t>
-            </a:r>
-          </a:p>
-          <a:p>
-            <a:r>
-              <a:rPr lang="en-GB"/>
-              <a:t>The diagnostic identifies the organisational conditions that help explain the behaviour:</a:t>
-            </a:r>
-          </a:p>
-          <a:p>
-            <a:r>
-              <a:rPr lang="en-GB"/>
-              <a:t>Evidence · Clog · How it constrains performance</a:t>
-            </a:r>
-          </a:p>
-          <a:p>
-            <a:r>
-              <a:rPr lang="en-GB"/>
-              <a:t>40% of delayed cases require another department. · Structural Misfit · Fragmented ownership and weak cross-functional handoffs delay resolution.</a:t>
-            </a:r>
-          </a:p>
-          <a:p>
-            <a:r>
-              <a:rPr lang="en-GB"/>
-              <a:t>Routine refunds require senior-management approval. · Decision Bottlenecks · People closest to the enquiry lack sufficient authority to resolve it.</a:t>
-            </a:r>
-          </a:p>
-          <a:p>
-            <a:r>
-              <a:rPr lang="en-GB"/>
-              <a:t>Employee scorecards emphasise enquiries processed. · Misaligned Metrics &amp; Incentives · Volume is reinforced more strongly than complete and timely resolution.</a:t>
-            </a:r>
-          </a:p>
-          <a:p>
-            <a:r>
-              <a:rPr lang="en-GB"/>
-              <a:t>Employees cannot track cases after escalation. · Technology / Infrastructure Lag · Fragmented information prevents timely follow-through.</a:t>
-            </a:r>
-          </a:p>
-          <a:p>
-            <a:r>
-              <a:rPr lang="en-GB"/>
-              <a:t>Organisational performance interpretation</a:t>
-            </a:r>
-          </a:p>
-          <a:p>
-            <a:r>
-              <a:rPr lang="en-GB"/>
-              <a:t>The coordination processes, decision rights, measures and information systems are not sufficiently aligned to the customer-resolution outcome. These conditions create recurring delays across the service chain.</a:t>
-            </a:r>
-          </a:p>
-          <a:p>
-            <a:r>
-              <a:rPr lang="en-GB"/>
-              <a:t>People performance interpretation</a:t>
-            </a:r>
-          </a:p>
-          <a:p>
-            <a:r>
-              <a:rPr lang="en-GB"/>
-              <a:t>Customer service employees may complete assigned tasks but still lack the authority, information and cross-functional support needed to resolve cases. Any individual capability or behavioural gaps must be assessed against these conditions and the standards within each person’s control.</a:t>
-            </a:r>
-          </a:p>
-          <a:p>
-            <a:r>
-              <a:rPr lang="en-GB"/>
-              <a:t>Strategic interpretation</a:t>
-            </a:r>
-          </a:p>
-          <a:p>
-            <a:r>
-              <a:rPr lang="en-GB"/>
-              <a:t>The customer value proposition promises responsive service, but operating arrangements do not consistently enable its delivery. The principal ABCV distortion concerns the Value Proposition, with contributing constraints in Boundaries and Competition.</a:t>
-            </a:r>
-          </a:p>
-          <a:p>
-            <a:r>
-              <a:rPr lang="en-GB"/>
-              <a:t>Required management response</a:t>
-            </a:r>
-          </a:p>
-          <a:p>
-            <a:r>
-              <a:rPr lang="en-GB"/>
-              <a:t>Clarify end-to-end resolution ownership, adjust routine decision authority, align measures to resolution outcomes and improve case visibility across departments. Provide coaching or accountability interventions where evidence confirms individual capability or behavioural gaps.</a:t>
-            </a:r>
-          </a:p>
-          <a:p>
-            <a:r>
-              <a:rPr lang="en-GB"/>
-              <a:t>Closing Diagnostic Principle</a:t>
-            </a:r>
-          </a:p>
-          <a:p>
-            <a:r>
-              <a:rPr lang="en-GB"/>
-              <a:t>Performance is produced through people operating within an organisational system. A sound diagnosis examines the result, the behaviours shaping contributions and the organisational conditions that enable or constrain them.</a:t>
-            </a:r>
-          </a:p>
-          <a:p>
-            <a:r>
-              <a:rPr lang="en-GB"/>
-              <a:t>The 7-Clog Diagnostic Map helps leaders identify where these relationships have become misaligned, which ABCV elements are affected and what must change to restore performance.</a:t>
-            </a:r>
-          </a:p>
-          <a:p>
-            <a:endParaRPr lang="en-GB"/>
-          </a:p>
-          <a:p>
-            <a:r>
-              <a:rPr lang="en-GB"/>
-              <a:t>Participant file — what participants complete:</a:t>
-            </a:r>
-          </a:p>
-          <a:p>
-            <a:r>
-              <a:rPr lang="en-GB"/>
-              <a:t>- ✎ Reflection — Which Clogs Are Active? — Rate each clog in your current strategy portfolio (1 = absent, 5 = active). Then name the clog most active in your organisation, and the organisational condition it sits in.</a:t>
             </a:r>
           </a:p>
           <a:p>
@@ -7364,35 +8288,133 @@
           <a:lstStyle/>
           <a:p>
             <a:r>
-              <a:rPr lang="en-US" dirty="0"/>
-              <a:t>SECTION 2 · INTELLIGENCE — WHY
-Why Clogs Are Predictable Features of Execution
-Understanding why execution friction is the inevitable consequence of system misalignment — and introducing the 7 Strategic Unclogging Levers as the leadership toolkit for restoring execution flow.
-Section learning outcomes:
-1. Select and apply responses to strategic clogs across people and organisational performance.
-2. Intervene early in emerging execution friction before it compounds.
-HOW TO TEACH THE SECTION:
-The ignition point of this section is the mindset shift: from “Why is the strategy failing?” to “Where are our people and our organisational conditions not yet ready to carry the strategy?” This is a fundamentally different diagnostic posture that moves leadership from blame to engineering.
-Spend time on the pressure point examples — they make the abstract concrete. A strategy requiring cross-functional coordination will expose structural misfits. A strategy requiring decentralised execution will expose decision bottlenecks. These are predictable, based on the design gap between what the strategy demands and what the system can currently provide.
-For the 7 levers: make clear that levers are structural adjustments. Rarely does a single lever clear a clog alone. The diagnostic question is always: which lever combination addresses the root cause?
-Time: the facilitator file gives no minute timing for this section (see the Timing watch point in the Session Overview).</a:t>
-            </a:r>
-            <a:endParaRPr lang="en-US" dirty="0"/>
-          </a:p>
-          <a:p/>
-          <a:p>
-            <a:r>
+              <a:rPr lang="en-GB"/>
+              <a:t>SECTION 2 · INTELLIGENCE — WHY</a:t>
+            </a:r>
+          </a:p>
+          <a:p>
+            <a:r>
+              <a:rPr lang="en-GB"/>
+              <a:t>Why Disciplined Intervention Clears Strategic Clogs</a:t>
+            </a:r>
+          </a:p>
+          <a:p>
+            <a:r>
+              <a:rPr lang="en-GB"/>
+              <a:t>Building the three disciplines that detect, classify and resolve strategic clogs, and applying the 7 Strategic Unclogging Levers across people and organisational performance.</a:t>
+            </a:r>
+          </a:p>
+          <a:p>
+            <a:endParaRPr lang="en-GB"/>
+          </a:p>
+          <a:p>
+            <a:r>
+              <a:rPr lang="en-GB"/>
+              <a:t>Section learning outcomes:</a:t>
+            </a:r>
+          </a:p>
+          <a:p>
+            <a:r>
+              <a:rPr lang="en-GB"/>
+              <a:t>1. Select and apply responses to strategic clogs across people and organisational performance.</a:t>
+            </a:r>
+          </a:p>
+          <a:p>
+            <a:r>
+              <a:rPr lang="en-GB"/>
+              <a:t>2. Intervene early in emerging execution friction before it compounds.</a:t>
+            </a:r>
+          </a:p>
+          <a:p>
+            <a:endParaRPr lang="en-GB"/>
+          </a:p>
+          <a:p>
+            <a:r>
+              <a:rPr lang="en-GB"/>
+              <a:t>HOW TO TEACH THE SECTION:</a:t>
+            </a:r>
+          </a:p>
+          <a:p>
+            <a:r>
+              <a:rPr lang="en-GB"/>
+              <a:t>The ignition point of this section is the mindset shift: from “Why is the strategy failing?” to “Where are our people and our organisational conditions not yet ready to carry the strategy?” This is a fundamentally different diagnostic posture that moves leadership from blame to engineering.</a:t>
+            </a:r>
+          </a:p>
+          <a:p>
+            <a:r>
+              <a:rPr lang="en-GB"/>
+              <a:t>Open with the section narrative: a named clog still holds until leaders act on it. Then teach the three disciplines one at a time, each in people performance and in organisational performance: leaders detect the signals early, name the clog with the evidence of the three lines of sight, and intervene on the condition behind it.</a:t>
+            </a:r>
+          </a:p>
+          <a:p>
+            <a:r>
+              <a:rPr lang="en-GB"/>
+              <a:t>For the 7 levers: teach what each lever changes in people performance and in organisational performance. Rarely does a single lever clear a clog alone. The diagnostic question is always: which lever combination addresses the root cause?</a:t>
+            </a:r>
+          </a:p>
+          <a:p>
+            <a:endParaRPr lang="en-GB"/>
+          </a:p>
+          <a:p>
+            <a:r>
+              <a:rPr lang="en-GB"/>
+              <a:t>Section opening (on the page):</a:t>
+            </a:r>
+          </a:p>
+          <a:p>
+            <a:r>
+              <a:rPr lang="en-GB"/>
+              <a:t>Section 1 traced how a strategic clog forms and how it shows: in the result that falls short, in what individuals and teams are doing or unable to do, and in the organisational conditions behind their behaviour. A named clog still holds until leaders act on it.</a:t>
+            </a:r>
+          </a:p>
+          <a:p>
+            <a:r>
+              <a:rPr lang="en-GB"/>
+              <a:t>Leaders resolve clogs through three disciplines. They identify the clog early, while it is still a signal. They classify it accurately, so the response addresses its cause. They intervene with the lever that removes that cause. Each discipline is a habit the executive team builds through practice in every review.</a:t>
+            </a:r>
+          </a:p>
+          <a:p>
+            <a:r>
+              <a:rPr lang="en-GB"/>
+              <a:t>Early action matters because a clog compounds. The delay it causes in one function becomes the constraint on the next, and a matter that one adjustment would have resolved early grows into a recovery effort across several functions.</a:t>
+            </a:r>
+          </a:p>
+          <a:p>
+            <a:r>
+              <a:rPr lang="en-GB"/>
+              <a:t>Every response works on two sides at once. In people performance, it restores the authority, capability, focus and confidence individuals need to deliver their tasks. In organisational performance, it changes the structures, processes, systems, resources and governance so that they support the execution of those tasks. A response confined to one side leaves the clog in place on the other.</a:t>
+            </a:r>
+          </a:p>
+          <a:p>
+            <a:r>
+              <a:rPr lang="en-GB"/>
+              <a:t>Part 2.1 sets out the three disciplines. Part 2.2 sets out the 7 Strategic Unclogging Levers, the interventions leaders apply once the clog is named.</a:t>
+            </a:r>
+          </a:p>
+          <a:p>
+            <a:endParaRPr lang="en-GB"/>
+          </a:p>
+          <a:p>
+            <a:endParaRPr lang="en-GB"/>
+          </a:p>
+          <a:p>
+            <a:r>
+              <a:rPr lang="en-GB"/>
               <a:t>Source detail (S2R® manuscript):</a:t>
             </a:r>
           </a:p>
-          <a:p/>
-          <a:p>
-            <a:r>
+          <a:p>
+            <a:endParaRPr lang="en-GB"/>
+          </a:p>
+          <a:p>
+            <a:r>
+              <a:rPr lang="en-GB"/>
               <a:t>Purpose of the unit: In complex systems, some level of friction is unavoidable, so eliminating clogs entirely is outside the purpose of this unit. The objective is to ensure that clogs are identified early, understood correctly, and addressed deliberately.</a:t>
             </a:r>
           </a:p>
           <a:p>
             <a:r>
+              <a:rPr lang="en-GB"/>
               <a:t>At that moment, the leadership team transitions from reacting to stalled initiatives to actively engineering the flow of execution. That shift marks the ignition point of execution mastery.</a:t>
             </a:r>
           </a:p>
@@ -7479,122 +8501,259 @@
           <a:lstStyle/>
           <a:p>
             <a:r>
-              <a:rPr lang="en-US" dirty="0"/>
-              <a:t>2.1 — CLOGS ARE DESIGN SIGNALS (The core argument)
-Content:
-When leaders define strategy, they design a future operating direction. When the organisation attempts to execute that strategy, it must do so through today’s operating system — its structure, decision rights, culture, metrics, capabilities, and technology. If any element of this system is misaligned with the new strategic direction, friction will appear. The friction is the natural consequence of system misalignment.
-This is why execution breakdowns usually occur because the organisation’s structure, capabilities, behaviours, or systems have not yet adapted to the strategy. The clog is therefore the signal that the system requires adjustment.
-Clogs emerge precisely where the strategy stretches the existing system beyond its current design capacity. A strategy requiring rapid cross-functional coordination will expose structural misfits. A strategy dependent on data-driven decisions will reveal capability gaps. A strategy requiring decentralised execution will expose decision bottlenecks. These pressures are predictable.
-Experienced leadership teams recognise this. They treat clogs as engineering signals indicating where the organisation must evolve. This transforms the role of the executive team: defining strategic direction and ensuring the organisation’s operating system can carry that direction without excessive friction.
-Participant file (2.1 — Clogs Are Design Signals) — prompts participants complete:
-- ✎ Reflection — Where Is Your System Not Yet Ready? — Given your current strategic direction — which element of your operating system is most likely to create friction? (Structure / Decision rights / Culture / Metrics / Capability / Technology) Why is this predictable given your strategy?</a:t>
-            </a:r>
-            <a:endParaRPr lang="en-US" dirty="0"/>
-          </a:p>
-          <a:p/>
-          <a:p>
-            <a:r>
+              <a:rPr lang="en-GB"/>
+              <a:t>1.2 — UNDERSTANDING WHERE PERFORMANCE BECOMES CONSTRAINED (Why clogs form · Two dimensions of performance)</a:t>
+            </a:r>
+          </a:p>
+          <a:p>
+            <a:endParaRPr lang="en-GB"/>
+          </a:p>
+          <a:p>
+            <a:r>
+              <a:rPr lang="en-GB"/>
+              <a:t>TEACHING NOTES:</a:t>
+            </a:r>
+          </a:p>
+          <a:p>
+            <a:r>
+              <a:rPr lang="en-GB"/>
+              <a:t>1.2 · Teach why clogs form where the strategy stretches today’s organisation, then the two dimensions of performance. Participants write the reflection on where their organisation is not yet ready in their own file.</a:t>
+            </a:r>
+          </a:p>
+          <a:p>
+            <a:endParaRPr lang="en-GB"/>
+          </a:p>
+          <a:p>
+            <a:r>
+              <a:rPr lang="en-GB"/>
+              <a:t>Content:</a:t>
+            </a:r>
+          </a:p>
+          <a:p>
+            <a:r>
+              <a:rPr lang="en-GB"/>
+              <a:t>When leaders define a strategy, they set a new direction for the organisation. The organisation executes that direction through what it has today: its structure, decision rights, culture, measures, capabilities and technology, and the ways of working its people have built within them. Where any of these has not yet adapted to the strategy, friction appears.</a:t>
+            </a:r>
+          </a:p>
+          <a:p>
+            <a:r>
+              <a:rPr lang="en-GB"/>
+              <a:t>Clogs form where the strategy stretches today’s organisation beyond what it was designed to carry. A strategy that requires rapid coordination across functions exposes Structural Misfit. A strategy that depends on data-driven decisions reveals Capability Gaps. A strategy that requires decisions closer to the customer exposes Decision Bottlenecks. Each strategy places its weight on known parts of the organisation, so leaders can anticipate where its clogs will form.</a:t>
+            </a:r>
+          </a:p>
+          <a:p>
+            <a:r>
+              <a:rPr lang="en-GB"/>
+              <a:t>Experienced leadership teams read a clog as a signal of where the organisation must adapt next. Setting the direction is one part of their role; ensuring the organisation can carry it is the other. To read the signal, leaders examine where performance becomes constrained.</a:t>
+            </a:r>
+          </a:p>
+          <a:p>
+            <a:r>
+              <a:rPr lang="en-GB"/>
+              <a:t>Strategy depends on the organisation’s ability to convert its strategic intent into coordinated contributions and measurable results. This requires two connected dimensions of performance:</a:t>
+            </a:r>
+          </a:p>
+          <a:p>
+            <a:r>
+              <a:rPr lang="en-GB"/>
+              <a:t>Organisational performance</a:t>
+            </a:r>
+          </a:p>
+          <a:p>
+            <a:r>
+              <a:rPr lang="en-GB"/>
+              <a:t>The enterprise’s ability to create, deliver and sustain value. It reflects how effectively structures, processes, resources, capabilities, governance and operating systems work together to produce strategic outcomes.</a:t>
+            </a:r>
+          </a:p>
+          <a:p>
+            <a:r>
+              <a:rPr lang="en-GB"/>
+              <a:t>People performance</a:t>
+            </a:r>
+          </a:p>
+          <a:p>
+            <a:r>
+              <a:rPr lang="en-GB"/>
+              <a:t>How effectively individuals and teams understand expectations, make decisions, exercise judgement, apply capabilities, collaborate and deliver their contributions to organisational results.</a:t>
+            </a:r>
+          </a:p>
+          <a:p>
+            <a:r>
+              <a:rPr lang="en-GB"/>
+              <a:t>Both dimensions operate within the same enterprise system. When organisational conditions are weak, even capable and committed people may struggle to perform. They experience delays, conflicting priorities, unclear responsibilities, resource shortages and barriers beyond their authority to resolve.</a:t>
+            </a:r>
+          </a:p>
+          <a:p>
+            <a:r>
+              <a:rPr lang="en-GB"/>
+              <a:t>When people performance is weak, the organisation may have adequate resources and well-designed processes but still experience poor judgement, inconsistent behaviours, weak collaboration, limited ownership and unreliable delivery.</a:t>
+            </a:r>
+          </a:p>
+          <a:p>
+            <a:r>
+              <a:rPr lang="en-GB"/>
+              <a:t>These conditions often reinforce one another. For example, unclear decision rights create hesitation among managers. Repeated hesitation then encourages senior leaders to centralise decisions further, increasing the original bottleneck.</a:t>
+            </a:r>
+          </a:p>
+          <a:p>
+            <a:r>
+              <a:rPr lang="en-GB"/>
+              <a:t>The 7-Clog Diagnostic Map identifies seven recurring conditions that constrain the organisation’s capacity to deliver its strategy. The diagnostic examines both the condition of the organisational system and the performance patterns emerging within it.</a:t>
+            </a:r>
+          </a:p>
+          <a:p>
+            <a:endParaRPr lang="en-GB"/>
+          </a:p>
+          <a:p>
+            <a:r>
+              <a:rPr lang="en-GB"/>
+              <a:t>Participant file — what participants complete:</a:t>
+            </a:r>
+          </a:p>
+          <a:p>
+            <a:r>
+              <a:rPr lang="en-GB"/>
+              <a:t>- ✎ Reflection — Where Is Your System Not Yet Ready? — the element of their operating system most likely to create friction under their current strategic direction, and why this is predictable given their strategy.</a:t>
+            </a:r>
+          </a:p>
+          <a:p>
+            <a:endParaRPr lang="en-GB"/>
+          </a:p>
+          <a:p>
+            <a:r>
+              <a:rPr lang="en-GB"/>
               <a:t>Source detail (S2R® manuscript):</a:t>
             </a:r>
           </a:p>
-          <a:p/>
-          <a:p>
-            <a:r>
+          <a:p>
+            <a:endParaRPr lang="en-GB"/>
+          </a:p>
+          <a:p>
+            <a:r>
+              <a:rPr lang="en-GB"/>
               <a:t>Today’s operating system in full. That system includes:</a:t>
             </a:r>
           </a:p>
           <a:p>
             <a:r>
+              <a:rPr lang="en-GB"/>
               <a:t>- organisational structure</a:t>
             </a:r>
           </a:p>
           <a:p>
             <a:r>
+              <a:rPr lang="en-GB"/>
               <a:t>- decision rights and governance pathways</a:t>
             </a:r>
           </a:p>
           <a:p>
             <a:r>
+              <a:rPr lang="en-GB"/>
               <a:t>- cultural norms and behavioural expectations</a:t>
             </a:r>
           </a:p>
           <a:p>
             <a:r>
+              <a:rPr lang="en-GB"/>
               <a:t>- performance metrics and incentives</a:t>
             </a:r>
           </a:p>
           <a:p>
             <a:r>
+              <a:rPr lang="en-GB"/>
               <a:t>- capabilities, skills, and leadership capacity</a:t>
             </a:r>
           </a:p>
           <a:p>
             <a:r>
+              <a:rPr lang="en-GB"/>
               <a:t>- technology platforms and operational infrastructure</a:t>
             </a:r>
           </a:p>
-          <a:p/>
-          <a:p>
-            <a:r>
+          <a:p>
+            <a:endParaRPr lang="en-GB"/>
+          </a:p>
+          <a:p>
+            <a:r>
+              <a:rPr lang="en-GB"/>
               <a:t>Clogs emerge at organisational pressure points. The four examples in full:</a:t>
             </a:r>
           </a:p>
           <a:p>
             <a:r>
+              <a:rPr lang="en-GB"/>
               <a:t>- A strategy requiring rapid cross-functional coordination will expose structural misfits in reporting lines and governance processes.</a:t>
             </a:r>
           </a:p>
           <a:p>
             <a:r>
+              <a:rPr lang="en-GB"/>
               <a:t>- A strategy dependent on data-driven decision-making will reveal capability gaps in analytical skills and technology platforms.</a:t>
             </a:r>
           </a:p>
           <a:p>
             <a:r>
+              <a:rPr lang="en-GB"/>
               <a:t>- A strategy requiring decentralised execution will expose decision bottlenecks embedded in hierarchical approval structures.</a:t>
             </a:r>
           </a:p>
           <a:p>
             <a:r>
+              <a:rPr lang="en-GB"/>
               <a:t>- A strategy dependent on collaboration will surface cultural resistance where incentives reward individual performance.</a:t>
             </a:r>
           </a:p>
-          <a:p/>
-          <a:p>
-            <a:r>
+          <a:p>
+            <a:endParaRPr lang="en-GB"/>
+          </a:p>
+          <a:p>
+            <a:r>
+              <a:rPr lang="en-GB"/>
               <a:t>The mindset: Experienced leadership teams recognise that execution friction is a normal consequence of strategic change. Moving from the question “Why is the strategy failing?” to the question on the slide reframes execution from reactive troubleshooting to proactive execution architecture.</a:t>
             </a:r>
           </a:p>
           <a:p>
             <a:r>
+              <a:rPr lang="en-GB"/>
               <a:t>The CXO role: Within the DIG framework, the CXO plays a critical role in managing execution flow. Their responsibility is to detect and manage clogs before they compound into systemic execution failures.</a:t>
             </a:r>
           </a:p>
-          <a:p/>
-          <a:p>
-            <a:r>
+          <a:p>
+            <a:endParaRPr lang="en-GB"/>
+          </a:p>
+          <a:p>
+            <a:r>
+              <a:rPr lang="en-GB"/>
               <a:t>Professional insights:</a:t>
             </a:r>
           </a:p>
-          <a:p/>
-          <a:p>
-            <a:r>
+          <a:p>
+            <a:endParaRPr lang="en-GB"/>
+          </a:p>
+          <a:p>
+            <a:r>
+              <a:rPr lang="en-GB"/>
               <a:t>Resistance is predictable: The first response to significant change is almost always resistance and escalation, and intensifying friction can be evidence that the direction is right. Plan for the first phase of resistance before launching the change.</a:t>
             </a:r>
           </a:p>
           <a:p>
             <a:r>
+              <a:rPr lang="en-GB"/>
               <a:t>Source: Journal, 5 February 2026 — Professional Insights: Strategy</a:t>
             </a:r>
           </a:p>
-          <a:p/>
-          <a:p>
-            <a:r>
+          <a:p>
+            <a:endParaRPr lang="en-GB"/>
+          </a:p>
+          <a:p>
+            <a:r>
+              <a:rPr lang="en-GB"/>
               <a:t>A structural problem: Leaders caught between what they know is right and what their environment allows must address the environment as well as the decision. The problem is structural.</a:t>
             </a:r>
           </a:p>
           <a:p>
             <a:r>
+              <a:rPr lang="en-GB"/>
               <a:t>Source: Journal, 17 February 2026 — Professional Insights: Leadership</a:t>
             </a:r>
           </a:p>
@@ -8265,7 +9424,7 @@
                 <a:ea typeface="Calibri" pitchFamily="34" charset="-122"/>
                 <a:cs typeface="Calibri" pitchFamily="34" charset="-120"/>
               </a:rPr>
-              <a:t>2.1 · Clogs are design signals</a:t>
+              <a:t>1.2 · Where performance becomes constrained</a:t>
             </a:r>
             <a:endParaRPr lang="en-US" sz="2600" dirty="0"/>
           </a:p>
@@ -8343,7 +9502,7 @@
                 <a:ea typeface="Calibri" pitchFamily="34" charset="-122"/>
                 <a:cs typeface="Calibri" pitchFamily="34" charset="-120"/>
               </a:rPr>
-              <a:t>Clogs emerge precisely where the strategy stretches the existing system beyond its current design capacity.</a:t>
+              <a:t>Clogs form where the strategy stretches today’s organisation beyond what it was designed to carry.</a:t>
             </a:r>
             <a:endParaRPr lang="en-US" sz="2400" dirty="0"/>
           </a:p>
@@ -8414,7 +9573,7 @@
                 <a:ea typeface="Cambria" pitchFamily="34" charset="-122"/>
                 <a:cs typeface="Cambria" pitchFamily="34" charset="-120"/>
               </a:rPr>
-              <a:t>2.2 · Three disciplines of execution engineering</a:t>
+              <a:t>2.1 · Three disciplines of execution engineering</a:t>
             </a:r>
             <a:endParaRPr lang="en-US" sz="3600" dirty="0"/>
           </a:p>
@@ -9041,7 +10200,7 @@
                 <a:ea typeface="Cambria" pitchFamily="34" charset="-122"/>
                 <a:cs typeface="Cambria" pitchFamily="34" charset="-120"/>
               </a:rPr>
-              <a:t>2.3 · The 7 Strategic Unclogging Levers</a:t>
+              <a:t>2.2 · The 7 Strategic Unclogging Levers</a:t>
             </a:r>
             <a:endParaRPr lang="en-US" sz="3600" dirty="0"/>
           </a:p>
@@ -9855,14 +11014,14 @@
       </p:sp>
       <p:pic>
         <p:nvPicPr>
-          <p:cNvPr id="3" name="Reflection 2.1" descr="ref_2.1.png"/>
+          <p:cNvPr id="5" name="Reflection 2.2" descr="ref_2.3.png"/>
           <p:cNvPicPr>
             <a:picLocks noChangeAspect="1"/>
           </p:cNvPicPr>
           <p:nvPr/>
         </p:nvPicPr>
         <p:blipFill>
-          <a:blip r:embed="rId10"/>
+          <a:blip r:embed="rId11"/>
           <a:stretch>
             <a:fillRect/>
           </a:stretch>
@@ -9879,7 +11038,7 @@
       </p:pic>
       <p:sp>
         <p:nvSpPr>
-          <p:cNvPr id="4" name="Part 2.1"/>
+          <p:cNvPr id="6" name="Part 2.2"/>
           <p:cNvSpPr/>
           <p:nvPr/>
         </p:nvSpPr>
@@ -9913,72 +11072,7 @@
                 </a:solidFill>
                 <a:latin typeface="Calibri"/>
               </a:rPr>
-              <a:t>2.1</a:t>
-            </a:r>
-          </a:p>
-        </p:txBody>
-      </p:sp>
-      <p:pic>
-        <p:nvPicPr>
-          <p:cNvPr id="5" name="Reflection 2.3" descr="ref_2.3.png"/>
-          <p:cNvPicPr>
-            <a:picLocks noChangeAspect="1"/>
-          </p:cNvPicPr>
-          <p:nvPr/>
-        </p:nvPicPr>
-        <p:blipFill>
-          <a:blip r:embed="rId11"/>
-          <a:stretch>
-            <a:fillRect/>
-          </a:stretch>
-        </p:blipFill>
-        <p:spPr>
-          <a:xfrm>
-            <a:off x="1691640" y="3048698"/>
-            <a:ext cx="10058400" cy="1311339"/>
-          </a:xfrm>
-          <a:prstGeom prst="rect">
-            <a:avLst/>
-          </a:prstGeom>
-        </p:spPr>
-      </p:pic>
-      <p:sp>
-        <p:nvSpPr>
-          <p:cNvPr id="6" name="Part 2.3"/>
-          <p:cNvSpPr/>
-          <p:nvPr/>
-        </p:nvSpPr>
-        <p:spPr>
-          <a:xfrm>
-            <a:off x="548640" y="3270027"/>
-            <a:ext cx="868680" cy="868680"/>
-          </a:xfrm>
-          <a:prstGeom prst="ellipse">
-            <a:avLst/>
-          </a:prstGeom>
-          <a:solidFill>
-            <a:srgbClr val="C6A24C"/>
-          </a:solidFill>
-          <a:ln>
-            <a:solidFill>
-              <a:srgbClr val="C6A24C"/>
-            </a:solidFill>
-          </a:ln>
-          <a:effectLst/>
-        </p:spPr>
-        <p:txBody>
-          <a:bodyPr wrap="none" lIns="0" tIns="0" rIns="0" bIns="0" rtlCol="0" anchor="ctr"/>
-          <a:lstStyle/>
-          <a:p>
-            <a:pPr algn="ctr"/>
-            <a:r>
-              <a:rPr lang="en-GB" sz="2400" b="1">
-                <a:solidFill>
-                  <a:srgbClr val="FFFFFF"/>
-                </a:solidFill>
-                <a:latin typeface="Calibri"/>
-              </a:rPr>
-              <a:t>2.3</a:t>
+              <a:t>2.2</a:t>
             </a:r>
           </a:p>
         </p:txBody>
@@ -12678,7 +13772,7 @@
                 <a:ea typeface="Calibri" pitchFamily="34" charset="-122"/>
                 <a:cs typeface="Calibri" pitchFamily="34" charset="-120"/>
               </a:rPr>
-              <a:t>4.2 · REVIEW: establish the performance reality</a:t>
+              <a:t>4.2 · The Unclogging Cycle: REVIEW</a:t>
             </a:r>
             <a:endParaRPr lang="en-US" sz="2600" dirty="0"/>
           </a:p>
@@ -13266,7 +14360,7 @@
                 <a:ea typeface="Cambria" pitchFamily="34" charset="-122"/>
                 <a:cs typeface="Cambria" pitchFamily="34" charset="-120"/>
               </a:rPr>
-              <a:t>4.3 · REALIGN: collective executive ownership</a:t>
+              <a:t>4.2 · The Unclogging Cycle: REALIGN</a:t>
             </a:r>
             <a:endParaRPr lang="en-US" sz="3600" dirty="0"/>
           </a:p>
@@ -13886,7 +14980,7 @@
                 <a:ea typeface="Cambria" pitchFamily="34" charset="-122"/>
                 <a:cs typeface="Cambria" pitchFamily="34" charset="-120"/>
               </a:rPr>
-              <a:t>4.4 · RESTORE: activate the Seven Unclogging Levers</a:t>
+              <a:t>4.2 · The Unclogging Cycle: RESTORE</a:t>
             </a:r>
             <a:endParaRPr lang="en-US" sz="3600" dirty="0"/>
           </a:p>
@@ -14692,7 +15786,7 @@
                 <a:ea typeface="Cambria" pitchFamily="34" charset="-122"/>
                 <a:cs typeface="Cambria" pitchFamily="34" charset="-120"/>
               </a:rPr>
-              <a:t>4.5 · Worked example: Review–Realign–Restore</a:t>
+              <a:t>4.3 · Worked example: the Unclogging Cycle</a:t>
             </a:r>
             <a:endParaRPr lang="en-US" sz="3600" dirty="0"/>
           </a:p>
@@ -15378,7 +16472,7 @@
                 </a:solidFill>
                 <a:latin typeface="Calibri"/>
               </a:rPr>
-              <a:t>4.5</a:t>
+              <a:t>4.3</a:t>
             </a:r>
           </a:p>
         </p:txBody>
@@ -16578,7 +17672,7 @@
                 <a:ea typeface="Calibri" pitchFamily="34" charset="-122"/>
                 <a:cs typeface="Calibri" pitchFamily="34" charset="-120"/>
               </a:rPr>
-              <a:t>One challenge from the list documented before CESI began.</a:t>
+              <a:t>One challenge from your group’s Problem Charter.</a:t>
             </a:r>
             <a:endParaRPr lang="en-US" sz="2400" dirty="0"/>
           </a:p>
@@ -18655,7 +19749,7 @@
                 <a:ea typeface="Cambria" pitchFamily="34" charset="-122"/>
                 <a:cs typeface="Cambria" pitchFamily="34" charset="-120"/>
               </a:rPr>
-              <a:t>5.4 · Apply Review–Realign–Restore</a:t>
+              <a:t>5.4 · Simulate the Unclogging Cycle</a:t>
             </a:r>
             <a:endParaRPr lang="en-US" sz="3600" dirty="0"/>
           </a:p>
@@ -20391,6 +21485,388 @@
 </p:sld>
 </file>
 
+<file path=ppt/slides/slide32.xml><?xml version="1.0" encoding="utf-8"?>
+<p:sld xmlns:a="http://schemas.openxmlformats.org/drawingml/2006/main" xmlns:p="http://schemas.openxmlformats.org/presentationml/2006/main" xmlns:r="http://schemas.openxmlformats.org/officeDocument/2006/relationships">
+  <p:cSld>
+    <p:bg>
+      <p:bgPr>
+        <a:solidFill>
+          <a:srgbClr val="FFFFFF"/>
+        </a:solidFill>
+      </p:bgPr>
+    </p:bg>
+    <p:spTree>
+      <p:nvGrpSpPr>
+        <p:cNvPr id="1" name=""/>
+        <p:cNvGrpSpPr/>
+        <p:nvPr/>
+      </p:nvGrpSpPr>
+      <p:grpSpPr/>
+      <p:sp>
+        <p:nvSpPr>
+          <p:cNvPr id="2" name="Text 0"/>
+          <p:cNvSpPr txBox="1"/>
+          <p:nvPr/>
+        </p:nvSpPr>
+        <p:spPr>
+          <a:xfrm>
+            <a:off x="548640" y="411480"/>
+            <a:ext cx="11064240" cy="868680"/>
+          </a:xfrm>
+          <a:prstGeom prst="rect">
+            <a:avLst/>
+          </a:prstGeom>
+          <a:noFill/>
+          <a:ln/>
+        </p:spPr>
+        <p:txBody>
+          <a:bodyPr wrap="square" lIns="0" tIns="0" rIns="0" bIns="0" rtlCol="0" anchor="ctr"/>
+          <a:lstStyle/>
+          <a:p>
+            <a:pPr indent="0" marL="0">
+              <a:buNone/>
+            </a:pPr>
+            <a:r>
+              <a:rPr lang="en-US" sz="3600" b="1" dirty="0">
+                <a:solidFill>
+                  <a:srgbClr val="1A5C2C"/>
+                </a:solidFill>
+                <a:latin typeface="Cambria" pitchFamily="34" charset="0"/>
+                <a:ea typeface="Cambria" pitchFamily="34" charset="-122"/>
+                <a:cs typeface="Cambria" pitchFamily="34" charset="-120"/>
+              </a:rPr>
+              <a:t>1.5 · Worked example: improving customer service</a:t>
+            </a:r>
+            <a:endParaRPr lang="en-US" sz="3600" dirty="0"/>
+          </a:p>
+        </p:txBody>
+      </p:sp>
+      <p:sp>
+        <p:nvSpPr>
+          <p:cNvPr id="3" name="Shape 1"/>
+          <p:cNvSpPr/>
+          <p:nvPr/>
+        </p:nvSpPr>
+        <p:spPr>
+          <a:xfrm>
+            <a:off x="548640" y="1800225"/>
+            <a:ext cx="640080" cy="640080"/>
+          </a:xfrm>
+          <a:prstGeom prst="ellipse">
+            <a:avLst/>
+          </a:prstGeom>
+          <a:solidFill>
+            <a:srgbClr val="1A5C2C"/>
+          </a:solidFill>
+          <a:ln w="12700">
+            <a:solidFill>
+              <a:srgbClr val="1A5C2C"/>
+            </a:solidFill>
+            <a:prstDash val="solid"/>
+          </a:ln>
+        </p:spPr>
+        <p:txBody>
+          <a:bodyPr/>
+          <a:p/>
+        </p:txBody>
+      </p:sp>
+      <p:pic>
+        <p:nvPicPr>
+          <p:cNvPr id="4" name="Image 0" descr="preencoded.png">    </p:cNvPr>
+          <p:cNvPicPr>
+            <a:picLocks noChangeAspect="1"/>
+          </p:cNvPicPr>
+          <p:nvPr/>
+        </p:nvPicPr>
+        <p:blipFill>
+          <a:blip r:embed="rId2"/>
+          <a:stretch>
+            <a:fillRect/>
+          </a:stretch>
+        </p:blipFill>
+        <p:spPr>
+          <a:xfrm>
+            <a:off x="708660" y="1960245"/>
+            <a:ext cx="320040" cy="320040"/>
+          </a:xfrm>
+          <a:prstGeom prst="rect">
+            <a:avLst/>
+          </a:prstGeom>
+        </p:spPr>
+      </p:pic>
+      <p:sp>
+        <p:nvSpPr>
+          <p:cNvPr id="5" name="Text 2"/>
+          <p:cNvSpPr txBox="1"/>
+          <p:nvPr/>
+        </p:nvSpPr>
+        <p:spPr>
+          <a:xfrm>
+            <a:off x="1508760" y="1508760"/>
+            <a:ext cx="10131552" cy="1223010"/>
+          </a:xfrm>
+          <a:prstGeom prst="rect">
+            <a:avLst/>
+          </a:prstGeom>
+          <a:noFill/>
+          <a:ln/>
+        </p:spPr>
+        <p:txBody>
+          <a:bodyPr wrap="square" lIns="0" tIns="0" rIns="0" bIns="0" rtlCol="0" anchor="ctr"/>
+          <a:lstStyle/>
+          <a:p>
+            <a:pPr indent="0" marL="0">
+              <a:buNone/>
+            </a:pPr>
+            <a:r>
+              <a:rPr lang="en-US" sz="2600" b="1" dirty="0">
+                <a:solidFill>
+                  <a:srgbClr val="1A5C2C"/>
+                </a:solidFill>
+                <a:latin typeface="Cambria" pitchFamily="34" charset="0"/>
+                <a:ea typeface="Cambria" pitchFamily="34" charset="-122"/>
+                <a:cs typeface="Cambria" pitchFamily="34" charset="-120"/>
+              </a:rPr>
+              <a:t>1  Performance outcome  </a:t>
+            </a:r>
+            <a:pPr indent="0" marL="0">
+              <a:buNone/>
+            </a:pPr>
+            <a:r>
+              <a:rPr lang="en-US" sz="2600" dirty="0">
+                <a:solidFill>
+                  <a:srgbClr val="1F2A22"/>
+                </a:solidFill>
+                <a:latin typeface="Calibri" pitchFamily="34" charset="0"/>
+                <a:ea typeface="Calibri" pitchFamily="34" charset="-122"/>
+                <a:cs typeface="Calibri" pitchFamily="34" charset="-120"/>
+              </a:rPr>
+              <a:t>65% of enquiries resolved within 48 hours, against 90%.</a:t>
+            </a:r>
+            <a:endParaRPr lang="en-US" sz="2600" dirty="0"/>
+          </a:p>
+        </p:txBody>
+      </p:sp>
+      <p:sp>
+        <p:nvSpPr>
+          <p:cNvPr id="6" name="Shape 3"/>
+          <p:cNvSpPr/>
+          <p:nvPr/>
+        </p:nvSpPr>
+        <p:spPr>
+          <a:xfrm>
+            <a:off x="548640" y="3023235"/>
+            <a:ext cx="640080" cy="640080"/>
+          </a:xfrm>
+          <a:prstGeom prst="ellipse">
+            <a:avLst/>
+          </a:prstGeom>
+          <a:solidFill>
+            <a:srgbClr val="1A5C2C"/>
+          </a:solidFill>
+          <a:ln w="12700">
+            <a:solidFill>
+              <a:srgbClr val="1A5C2C"/>
+            </a:solidFill>
+            <a:prstDash val="solid"/>
+          </a:ln>
+        </p:spPr>
+        <p:txBody>
+          <a:bodyPr/>
+          <a:p/>
+        </p:txBody>
+      </p:sp>
+      <p:pic>
+        <p:nvPicPr>
+          <p:cNvPr id="7" name="Image 1" descr="preencoded.png">    </p:cNvPr>
+          <p:cNvPicPr>
+            <a:picLocks noChangeAspect="1"/>
+          </p:cNvPicPr>
+          <p:nvPr/>
+        </p:nvPicPr>
+        <p:blipFill>
+          <a:blip r:embed="rId3"/>
+          <a:stretch>
+            <a:fillRect/>
+          </a:stretch>
+        </p:blipFill>
+        <p:spPr>
+          <a:xfrm>
+            <a:off x="708660" y="3183255"/>
+            <a:ext cx="320040" cy="320040"/>
+          </a:xfrm>
+          <a:prstGeom prst="rect">
+            <a:avLst/>
+          </a:prstGeom>
+        </p:spPr>
+      </p:pic>
+      <p:sp>
+        <p:nvSpPr>
+          <p:cNvPr id="8" name="Text 4"/>
+          <p:cNvSpPr txBox="1"/>
+          <p:nvPr/>
+        </p:nvSpPr>
+        <p:spPr>
+          <a:xfrm>
+            <a:off x="1508760" y="2731770"/>
+            <a:ext cx="10131552" cy="1223010"/>
+          </a:xfrm>
+          <a:prstGeom prst="rect">
+            <a:avLst/>
+          </a:prstGeom>
+          <a:noFill/>
+          <a:ln/>
+        </p:spPr>
+        <p:txBody>
+          <a:bodyPr wrap="square" lIns="0" tIns="0" rIns="0" bIns="0" rtlCol="0" anchor="ctr"/>
+          <a:lstStyle/>
+          <a:p>
+            <a:pPr indent="0" marL="0">
+              <a:buNone/>
+            </a:pPr>
+            <a:r>
+              <a:rPr lang="en-US" sz="2600" b="1" dirty="0">
+                <a:solidFill>
+                  <a:srgbClr val="1A5C2C"/>
+                </a:solidFill>
+                <a:latin typeface="Cambria" pitchFamily="34" charset="0"/>
+                <a:ea typeface="Cambria" pitchFamily="34" charset="-122"/>
+                <a:cs typeface="Cambria" pitchFamily="34" charset="-120"/>
+              </a:rPr>
+              <a:t>2  Performance behaviour  </a:t>
+            </a:r>
+            <a:pPr indent="0" marL="0">
+              <a:buNone/>
+            </a:pPr>
+            <a:r>
+              <a:rPr lang="en-US" sz="2600" dirty="0">
+                <a:solidFill>
+                  <a:srgbClr val="1F2A22"/>
+                </a:solidFill>
+                <a:latin typeface="Calibri" pitchFamily="34" charset="0"/>
+                <a:ea typeface="Calibri" pitchFamily="34" charset="-122"/>
+                <a:cs typeface="Calibri" pitchFamily="34" charset="-120"/>
+              </a:rPr>
+              <a:t>Cases pass between departments; routine refunds wait for approval.</a:t>
+            </a:r>
+            <a:endParaRPr lang="en-US" sz="2600" dirty="0"/>
+          </a:p>
+        </p:txBody>
+      </p:sp>
+      <p:sp>
+        <p:nvSpPr>
+          <p:cNvPr id="9" name="Shape 5"/>
+          <p:cNvSpPr/>
+          <p:nvPr/>
+        </p:nvSpPr>
+        <p:spPr>
+          <a:xfrm>
+            <a:off x="548640" y="4246245"/>
+            <a:ext cx="640080" cy="640080"/>
+          </a:xfrm>
+          <a:prstGeom prst="ellipse">
+            <a:avLst/>
+          </a:prstGeom>
+          <a:solidFill>
+            <a:srgbClr val="1A5C2C"/>
+          </a:solidFill>
+          <a:ln w="12700">
+            <a:solidFill>
+              <a:srgbClr val="1A5C2C"/>
+            </a:solidFill>
+            <a:prstDash val="solid"/>
+          </a:ln>
+        </p:spPr>
+        <p:txBody>
+          <a:bodyPr/>
+          <a:p/>
+        </p:txBody>
+      </p:sp>
+      <p:pic>
+        <p:nvPicPr>
+          <p:cNvPr id="10" name="Image 2" descr="preencoded.png">    </p:cNvPr>
+          <p:cNvPicPr>
+            <a:picLocks noChangeAspect="1"/>
+          </p:cNvPicPr>
+          <p:nvPr/>
+        </p:nvPicPr>
+        <p:blipFill>
+          <a:blip r:embed="rId4"/>
+          <a:stretch>
+            <a:fillRect/>
+          </a:stretch>
+        </p:blipFill>
+        <p:spPr>
+          <a:xfrm>
+            <a:off x="708660" y="4406265"/>
+            <a:ext cx="320040" cy="320040"/>
+          </a:xfrm>
+          <a:prstGeom prst="rect">
+            <a:avLst/>
+          </a:prstGeom>
+        </p:spPr>
+      </p:pic>
+      <p:sp>
+        <p:nvSpPr>
+          <p:cNvPr id="11" name="Text 6"/>
+          <p:cNvSpPr txBox="1"/>
+          <p:nvPr/>
+        </p:nvSpPr>
+        <p:spPr>
+          <a:xfrm>
+            <a:off x="1508760" y="3954780"/>
+            <a:ext cx="10131552" cy="1223010"/>
+          </a:xfrm>
+          <a:prstGeom prst="rect">
+            <a:avLst/>
+          </a:prstGeom>
+          <a:noFill/>
+          <a:ln/>
+        </p:spPr>
+        <p:txBody>
+          <a:bodyPr wrap="square" lIns="0" tIns="0" rIns="0" bIns="0" rtlCol="0" anchor="ctr"/>
+          <a:lstStyle/>
+          <a:p>
+            <a:pPr indent="0" marL="0">
+              <a:buNone/>
+            </a:pPr>
+            <a:r>
+              <a:rPr lang="en-US" sz="2600" b="1" dirty="0">
+                <a:solidFill>
+                  <a:srgbClr val="1A5C2C"/>
+                </a:solidFill>
+                <a:latin typeface="Cambria" pitchFamily="34" charset="0"/>
+                <a:ea typeface="Cambria" pitchFamily="34" charset="-122"/>
+                <a:cs typeface="Cambria" pitchFamily="34" charset="-120"/>
+              </a:rPr>
+              <a:t>3  Performance condition  </a:t>
+            </a:r>
+            <a:pPr indent="0" marL="0">
+              <a:buNone/>
+            </a:pPr>
+            <a:r>
+              <a:rPr lang="en-US" sz="2600" dirty="0">
+                <a:solidFill>
+                  <a:srgbClr val="1F2A22"/>
+                </a:solidFill>
+                <a:latin typeface="Calibri" pitchFamily="34" charset="0"/>
+                <a:ea typeface="Calibri" pitchFamily="34" charset="-122"/>
+                <a:cs typeface="Calibri" pitchFamily="34" charset="-120"/>
+              </a:rPr>
+              <a:t>Structural Misfit, Decision Bottlenecks, Misaligned Metrics, Technology Lag.</a:t>
+            </a:r>
+            <a:endParaRPr lang="en-US" sz="2600" dirty="0"/>
+          </a:p>
+        </p:txBody>
+      </p:sp>
+    </p:spTree>
+  </p:cSld>
+  <p:clrMapOvr>
+    <a:masterClrMapping/>
+  </p:clrMapOvr>
+</p:sld>
+</file>
+
 <file path=ppt/slides/slide4.xml><?xml version="1.0" encoding="utf-8"?>
 <p:sld xmlns:a="http://schemas.openxmlformats.org/drawingml/2006/main" xmlns:r="http://schemas.openxmlformats.org/officeDocument/2006/relationships" xmlns:p="http://schemas.openxmlformats.org/presentationml/2006/main">
   <p:cSld name="Slide 4">
@@ -21061,7 +22537,7 @@
                 <a:ea typeface="Cambria" pitchFamily="34" charset="-122"/>
                 <a:cs typeface="Cambria" pitchFamily="34" charset="-120"/>
               </a:rPr>
-              <a:t>1.2 · The 7-Clog Diagnostic Map</a:t>
+              <a:t>1.3 · The Seven Performance Clogs</a:t>
             </a:r>
             <a:endParaRPr lang="en-US" sz="3600" dirty="0"/>
           </a:p>
@@ -21867,7 +23343,7 @@
                 <a:ea typeface="Cambria" pitchFamily="34" charset="-122"/>
                 <a:cs typeface="Cambria" pitchFamily="34" charset="-120"/>
               </a:rPr>
-              <a:t>1.2.2 · Three performance lines of sight</a:t>
+              <a:t>1.4 · Three performance lines of sight</a:t>
             </a:r>
             <a:endParaRPr lang="en-US" sz="3600" dirty="0"/>
           </a:p>
@@ -22322,7 +23798,7 @@
       </p:sp>
       <p:pic>
         <p:nvPicPr>
-          <p:cNvPr id="5" name="Reflection 1.2" descr="ref_1.2.png"/>
+          <p:cNvPr id="5" name="Reflection 1.5" descr="ref_1.2.png"/>
           <p:cNvPicPr>
             <a:picLocks noChangeAspect="1"/>
           </p:cNvPicPr>
@@ -22336,6 +23812,71 @@
         </p:blipFill>
         <p:spPr>
           <a:xfrm>
+            <a:off x="1691640" y="4980205"/>
+            <a:ext cx="10058400" cy="1311339"/>
+          </a:xfrm>
+          <a:prstGeom prst="rect">
+            <a:avLst/>
+          </a:prstGeom>
+        </p:spPr>
+      </p:pic>
+      <p:sp>
+        <p:nvSpPr>
+          <p:cNvPr id="6" name="Part 1.5"/>
+          <p:cNvSpPr/>
+          <p:nvPr/>
+        </p:nvSpPr>
+        <p:spPr>
+          <a:xfrm>
+            <a:off x="548640" y="5201534"/>
+            <a:ext cx="868680" cy="868680"/>
+          </a:xfrm>
+          <a:prstGeom prst="ellipse">
+            <a:avLst/>
+          </a:prstGeom>
+          <a:solidFill>
+            <a:srgbClr val="C6A24C"/>
+          </a:solidFill>
+          <a:ln>
+            <a:solidFill>
+              <a:srgbClr val="C6A24C"/>
+            </a:solidFill>
+          </a:ln>
+          <a:effectLst/>
+        </p:spPr>
+        <p:txBody>
+          <a:bodyPr wrap="none" lIns="0" tIns="0" rIns="0" bIns="0" rtlCol="0" anchor="ctr"/>
+          <a:lstStyle/>
+          <a:p>
+            <a:pPr algn="ctr"/>
+            <a:r>
+              <a:rPr lang="en-GB" sz="2400" b="1">
+                <a:solidFill>
+                  <a:srgbClr val="FFFFFF"/>
+                </a:solidFill>
+                <a:latin typeface="Calibri"/>
+              </a:rPr>
+              <a:t>1.5</a:t>
+            </a:r>
+          </a:p>
+        </p:txBody>
+      </p:sp>
+      <p:pic>
+        <p:nvPicPr>
+          <p:cNvPr id="7" name="Reflection 1.2" descr="image.png"/>
+          <p:cNvPicPr>
+            <a:picLocks noChangeAspect="1"/>
+          </p:cNvPicPr>
+          <p:nvPr/>
+        </p:nvPicPr>
+        <p:blipFill>
+          <a:blip r:embed="rId12"/>
+          <a:stretch>
+            <a:fillRect/>
+          </a:stretch>
+        </p:blipFill>
+        <p:spPr>
+          <a:xfrm>
             <a:off x="1691640" y="3394546"/>
             <a:ext cx="10058400" cy="1311339"/>
           </a:xfrm>
@@ -22346,7 +23887,7 @@
       </p:pic>
       <p:sp>
         <p:nvSpPr>
-          <p:cNvPr id="6" name="Part 1.2"/>
+          <p:cNvPr id="8" name="Part 1.2"/>
           <p:cNvSpPr/>
           <p:nvPr/>
         </p:nvSpPr>
@@ -22567,7 +24108,7 @@
                 <a:ea typeface="Calibri" pitchFamily="34" charset="-122"/>
                 <a:cs typeface="Calibri" pitchFamily="34" charset="-120"/>
               </a:rPr>
-              <a:t>Why Clogs Are Predictable Features of Execution</a:t>
+              <a:t>Why Disciplined Intervention Clears Strategic Clogs</a:t>
             </a:r>
             <a:endParaRPr lang="en-US" sz="2600" dirty="0"/>
           </a:p>

</xml_diff>